<commit_message>
docs: refresh live submission collateral
</commit_message>
<xml_diff>
--- a/docs/submission/ThetaTrap-Hackathon-Deck.pptx
+++ b/docs/submission/ThetaTrap-Hackathon-Deck.pptx
@@ -2,18 +2,18 @@
 <file path=ppt/presentation.xml><?xml version="1.0" encoding="utf-8"?>
 <p:presentation xmlns:p="http://schemas.openxmlformats.org/presentationml/2006/main">
   <p:sldMasterIdLst>
-    <p:sldMasterId xmlns:r="http://schemas.openxmlformats.org/officeDocument/2006/relationships" id="2147483648" r:id="R11aff28be93e44d1"/>
+    <p:sldMasterId xmlns:r="http://schemas.openxmlformats.org/officeDocument/2006/relationships" id="2147483648" r:id="R939e468478be4864"/>
   </p:sldMasterIdLst>
   <p:notesMasterIdLst>
-    <p:notesMasterId xmlns:r="http://schemas.openxmlformats.org/officeDocument/2006/relationships" r:id="Rafb347d2c2924841"/>
+    <p:notesMasterId xmlns:r="http://schemas.openxmlformats.org/officeDocument/2006/relationships" r:id="R4ca6bd3af7484f81"/>
   </p:notesMasterIdLst>
   <p:sldIdLst>
-    <p:sldId xmlns:r="http://schemas.openxmlformats.org/officeDocument/2006/relationships" id="256" r:id="R7330052680df40b1"/>
-    <p:sldId xmlns:r="http://schemas.openxmlformats.org/officeDocument/2006/relationships" id="257" r:id="R3e812776bda24371"/>
-    <p:sldId xmlns:r="http://schemas.openxmlformats.org/officeDocument/2006/relationships" id="258" r:id="R2ccb14a5360d4848"/>
-    <p:sldId xmlns:r="http://schemas.openxmlformats.org/officeDocument/2006/relationships" id="259" r:id="Rc9cbd2f659f24a84"/>
-    <p:sldId xmlns:r="http://schemas.openxmlformats.org/officeDocument/2006/relationships" id="260" r:id="R2d4d4fdbe38241d5"/>
-    <p:sldId xmlns:r="http://schemas.openxmlformats.org/officeDocument/2006/relationships" id="261" r:id="R6056c159bc144ed4"/>
+    <p:sldId xmlns:r="http://schemas.openxmlformats.org/officeDocument/2006/relationships" id="256" r:id="Rd0bf93725e7a4f10"/>
+    <p:sldId xmlns:r="http://schemas.openxmlformats.org/officeDocument/2006/relationships" id="257" r:id="R952e735472c14552"/>
+    <p:sldId xmlns:r="http://schemas.openxmlformats.org/officeDocument/2006/relationships" id="258" r:id="Rca8ee887a75a42c5"/>
+    <p:sldId xmlns:r="http://schemas.openxmlformats.org/officeDocument/2006/relationships" id="259" r:id="Ra574c132cc2e4286"/>
+    <p:sldId xmlns:r="http://schemas.openxmlformats.org/officeDocument/2006/relationships" id="260" r:id="R01213394fa0844df"/>
+    <p:sldId xmlns:r="http://schemas.openxmlformats.org/officeDocument/2006/relationships" id="261" r:id="R28c9d5dc883d42b0"/>
   </p:sldIdLst>
   <p:sldSz cx="12192000" cy="6858000"/>
   <p:notesSz cx="6858000" cy="9144000"/>
@@ -802,7 +802,7 @@
           <a:lstStyle xmlns:a="http://schemas.openxmlformats.org/drawingml/2006/main"/>
           <a:p xmlns:a="http://schemas.openxmlformats.org/drawingml/2006/main">
             <a:r>
-              <a:t>State the actual competition result verbally from the live dashboard after broker reconciliation.</a:t>
+              <a:t>This screenshot is the live, disarmed competition baseline captured on August 31, 2026. State the actual competition result verbally only after broker reconciliation.</a:t>
             </a:r>
           </a:p>
           <a:p xmlns:a="http://schemas.openxmlformats.org/drawingml/2006/main">
@@ -813,6 +813,11 @@
           <a:p xmlns:a="http://schemas.openxmlformats.org/drawingml/2006/main">
             <a:r>
               <a:t>[Sources]</a:t>
+            </a:r>
+          </a:p>
+          <a:p xmlns:a="http://schemas.openxmlformats.org/drawingml/2006/main">
+            <a:r>
+              <a:t>- Live dashboard: https://104-236-77-186.sslip.io/</a:t>
             </a:r>
           </a:p>
           <a:p xmlns:a="http://schemas.openxmlformats.org/drawingml/2006/main">
@@ -980,7 +985,7 @@
   </p:cSld>
   <p:clrMap bg1="lt1" tx1="dk1" bg2="lt2" tx2="dk2" accent1="accent1" accent2="accent2" accent3="accent3" accent4="accent4" accent5="accent5" accent6="accent6" hlink="hlink" folHlink="folHlink"/>
   <p:sldLayoutIdLst>
-    <p:sldLayoutId xmlns:r="http://schemas.openxmlformats.org/officeDocument/2006/relationships" id="2147483649" r:id="R2fb0d67b92d6457f"/>
+    <p:sldLayoutId xmlns:r="http://schemas.openxmlformats.org/officeDocument/2006/relationships" id="2147483649" r:id="Ra770bf5ca42d4c12"/>
   </p:sldLayoutIdLst>
   <p:txStyles>
     <p:titleStyle>
@@ -1531,7 +1536,7 @@
           <p:cNvPr id="8" name="cover-eyebrow">
             <a:extLst xmlns:a="http://schemas.openxmlformats.org/drawingml/2006/main">
               <a:ext uri="{FF2B5EF4-FFF2-40B4-BE49-F238E27FC236}">
-                <a16:creationId xmlns:a16="http://schemas.microsoft.com/office/drawing/2014/main" id="{11393D7F-4026-4F21-9B23-68ED23522081}"/>
+                <a16:creationId xmlns:a16="http://schemas.microsoft.com/office/drawing/2014/main" id="{8B7D1CFE-7EC8-4018-9164-727B8D74B971}"/>
               </a:ext>
             </a:extLst>
           </p:cNvPr>
@@ -1587,7 +1592,7 @@
           <p:cNvPr id="2" name="cover-title">
             <a:extLst xmlns:a="http://schemas.openxmlformats.org/drawingml/2006/main">
               <a:ext uri="{FF2B5EF4-FFF2-40B4-BE49-F238E27FC236}">
-                <a16:creationId xmlns:a16="http://schemas.microsoft.com/office/drawing/2014/main" id="{4D0F0EE5-ED54-4416-8B05-2804FA1E9796}"/>
+                <a16:creationId xmlns:a16="http://schemas.microsoft.com/office/drawing/2014/main" id="{5FD901A4-43B6-4C52-9A26-CFB1D5E2F2C2}"/>
               </a:ext>
             </a:extLst>
           </p:cNvPr>
@@ -1643,7 +1648,7 @@
           <p:cNvPr id="3" name="cover-subtitle">
             <a:extLst xmlns:a="http://schemas.openxmlformats.org/drawingml/2006/main">
               <a:ext uri="{FF2B5EF4-FFF2-40B4-BE49-F238E27FC236}">
-                <a16:creationId xmlns:a16="http://schemas.microsoft.com/office/drawing/2014/main" id="{42815466-4B43-44FB-8D5C-6C8A892DC268}"/>
+                <a16:creationId xmlns:a16="http://schemas.microsoft.com/office/drawing/2014/main" id="{A130F083-1867-42E8-91EA-7FB569FE7112}"/>
               </a:ext>
             </a:extLst>
           </p:cNvPr>
@@ -1722,7 +1727,7 @@
           <p:cNvPr id="4" name="cover-body">
             <a:extLst xmlns:a="http://schemas.openxmlformats.org/drawingml/2006/main">
               <a:ext uri="{FF2B5EF4-FFF2-40B4-BE49-F238E27FC236}">
-                <a16:creationId xmlns:a16="http://schemas.microsoft.com/office/drawing/2014/main" id="{E68EC6BD-AAEC-41D6-9B5A-9E6EB14CE10F}"/>
+                <a16:creationId xmlns:a16="http://schemas.microsoft.com/office/drawing/2014/main" id="{A34936AF-2410-4024-AC08-775C1A3DAC1F}"/>
               </a:ext>
             </a:extLst>
           </p:cNvPr>
@@ -1778,7 +1783,7 @@
           <p:cNvPr id="5" name="cover-footer">
             <a:extLst xmlns:a="http://schemas.openxmlformats.org/drawingml/2006/main">
               <a:ext uri="{FF2B5EF4-FFF2-40B4-BE49-F238E27FC236}">
-                <a16:creationId xmlns:a16="http://schemas.microsoft.com/office/drawing/2014/main" id="{2F04748B-ACAA-4345-86BA-949EECFF5A3E}"/>
+                <a16:creationId xmlns:a16="http://schemas.microsoft.com/office/drawing/2014/main" id="{03CC7278-D16C-4E7D-B6CB-3F79AD3B704C}"/>
               </a:ext>
             </a:extLst>
           </p:cNvPr>
@@ -1838,7 +1843,7 @@
           <p:nvPr/>
         </p:nvPicPr>
         <p:blipFill>
-          <a:blip xmlns:r="http://schemas.openxmlformats.org/officeDocument/2006/relationships" xmlns:a="http://schemas.openxmlformats.org/drawingml/2006/main" r:embed="R3bdfaebde4a14934"/>
+          <a:blip xmlns:r="http://schemas.openxmlformats.org/officeDocument/2006/relationships" xmlns:a="http://schemas.openxmlformats.org/drawingml/2006/main" r:embed="R2b6ada7915454078"/>
           <a:srcRect xmlns:a="http://schemas.openxmlformats.org/drawingml/2006/main" l="26369" t="0" r="26369" b="0"/>
           <a:stretch xmlns:a="http://schemas.openxmlformats.org/drawingml/2006/main">
             <a:fillRect l="0" t="0" r="0" b="0"/>
@@ -1859,7 +1864,7 @@
           <p:cNvPr id="7" name="slide-number-1">
             <a:extLst xmlns:a="http://schemas.openxmlformats.org/drawingml/2006/main">
               <a:ext uri="{FF2B5EF4-FFF2-40B4-BE49-F238E27FC236}">
-                <a16:creationId xmlns:a16="http://schemas.microsoft.com/office/drawing/2014/main" id="{8B20E59D-2708-4E25-A3DE-A145254E4AAD}"/>
+                <a16:creationId xmlns:a16="http://schemas.microsoft.com/office/drawing/2014/main" id="{16687BAC-8037-4F1D-AAED-49AB35EAA5E9}"/>
               </a:ext>
             </a:extLst>
           </p:cNvPr>
@@ -1913,7 +1918,7 @@
     </p:spTree>
     <p:extLst>
       <p:ext uri="{BB962C8B-B14F-4D97-AF65-F5344CB8AC3E}">
-        <p14:creationId xmlns:p14="http://schemas.microsoft.com/office/powerpoint/2010/main" val="1047803884"/>
+        <p14:creationId xmlns:p14="http://schemas.microsoft.com/office/powerpoint/2010/main" val="44908004"/>
       </p:ext>
     </p:extLst>
   </p:cSld>
@@ -1944,7 +1949,7 @@
           <p:cNvPr id="22" name="eyebrow-2">
             <a:extLst xmlns:a="http://schemas.openxmlformats.org/drawingml/2006/main">
               <a:ext uri="{FF2B5EF4-FFF2-40B4-BE49-F238E27FC236}">
-                <a16:creationId xmlns:a16="http://schemas.microsoft.com/office/drawing/2014/main" id="{2AD5FEE3-8B74-4D37-AFDD-91321AA6435E}"/>
+                <a16:creationId xmlns:a16="http://schemas.microsoft.com/office/drawing/2014/main" id="{4222FA86-C55B-4EFC-89B9-3E266EC6449A}"/>
               </a:ext>
             </a:extLst>
           </p:cNvPr>
@@ -2000,7 +2005,7 @@
           <p:cNvPr id="2" name="title-2">
             <a:extLst xmlns:a="http://schemas.openxmlformats.org/drawingml/2006/main">
               <a:ext uri="{FF2B5EF4-FFF2-40B4-BE49-F238E27FC236}">
-                <a16:creationId xmlns:a16="http://schemas.microsoft.com/office/drawing/2014/main" id="{C36632DF-EF17-46B6-8AC1-5EC5F116A2A2}"/>
+                <a16:creationId xmlns:a16="http://schemas.microsoft.com/office/drawing/2014/main" id="{6249879B-288F-4D85-A7F2-644FC8C030CB}"/>
               </a:ext>
             </a:extLst>
           </p:cNvPr>
@@ -2056,7 +2061,7 @@
           <p:cNvPr id="3" name="slide-number-2">
             <a:extLst xmlns:a="http://schemas.openxmlformats.org/drawingml/2006/main">
               <a:ext uri="{FF2B5EF4-FFF2-40B4-BE49-F238E27FC236}">
-                <a16:creationId xmlns:a16="http://schemas.microsoft.com/office/drawing/2014/main" id="{3FBAAF85-7055-4774-8759-2CAEE3AF55EA}"/>
+                <a16:creationId xmlns:a16="http://schemas.microsoft.com/office/drawing/2014/main" id="{C297B402-3BDA-46DD-A0CE-3D09A14DB6CB}"/>
               </a:ext>
             </a:extLst>
           </p:cNvPr>
@@ -2112,7 +2117,7 @@
           <p:cNvPr id="4" name="origin-quote">
             <a:extLst xmlns:a="http://schemas.openxmlformats.org/drawingml/2006/main">
               <a:ext uri="{FF2B5EF4-FFF2-40B4-BE49-F238E27FC236}">
-                <a16:creationId xmlns:a16="http://schemas.microsoft.com/office/drawing/2014/main" id="{A89084D7-0AD2-4EC1-A9CC-D6450F9FC2E9}"/>
+                <a16:creationId xmlns:a16="http://schemas.microsoft.com/office/drawing/2014/main" id="{964EF0F5-DAE7-4018-B257-5D9D44249963}"/>
               </a:ext>
             </a:extLst>
           </p:cNvPr>
@@ -2191,7 +2196,7 @@
           <p:cNvPr id="5" name="origin-learning">
             <a:extLst xmlns:a="http://schemas.openxmlformats.org/drawingml/2006/main">
               <a:ext uri="{FF2B5EF4-FFF2-40B4-BE49-F238E27FC236}">
-                <a16:creationId xmlns:a16="http://schemas.microsoft.com/office/drawing/2014/main" id="{24C394B4-4D05-45FD-962F-9FED86EF8F2A}"/>
+                <a16:creationId xmlns:a16="http://schemas.microsoft.com/office/drawing/2014/main" id="{23314AD2-A451-4003-8FFF-C7D226739BA4}"/>
               </a:ext>
             </a:extLst>
           </p:cNvPr>
@@ -2247,7 +2252,7 @@
           <p:cNvPr id="6" name="step-rule-01">
             <a:extLst xmlns:a="http://schemas.openxmlformats.org/drawingml/2006/main">
               <a:ext uri="{FF2B5EF4-FFF2-40B4-BE49-F238E27FC236}">
-                <a16:creationId xmlns:a16="http://schemas.microsoft.com/office/drawing/2014/main" id="{92C62231-08A4-4E4D-B0E4-FC4E030F8E14}"/>
+                <a16:creationId xmlns:a16="http://schemas.microsoft.com/office/drawing/2014/main" id="{4339E59E-968A-4E00-9261-1B2F999BBCDB}"/>
               </a:ext>
             </a:extLst>
           </p:cNvPr>
@@ -2278,7 +2283,7 @@
           <p:cNvPr id="7" name="step-num-01">
             <a:extLst xmlns:a="http://schemas.openxmlformats.org/drawingml/2006/main">
               <a:ext uri="{FF2B5EF4-FFF2-40B4-BE49-F238E27FC236}">
-                <a16:creationId xmlns:a16="http://schemas.microsoft.com/office/drawing/2014/main" id="{337630E3-E40D-4A79-BBA8-9B7BC7B63BD8}"/>
+                <a16:creationId xmlns:a16="http://schemas.microsoft.com/office/drawing/2014/main" id="{70FD83DB-4F6D-43BF-9DBB-5A37A6231EC3}"/>
               </a:ext>
             </a:extLst>
           </p:cNvPr>
@@ -2334,7 +2339,7 @@
           <p:cNvPr id="8" name="step-title-01">
             <a:extLst xmlns:a="http://schemas.openxmlformats.org/drawingml/2006/main">
               <a:ext uri="{FF2B5EF4-FFF2-40B4-BE49-F238E27FC236}">
-                <a16:creationId xmlns:a16="http://schemas.microsoft.com/office/drawing/2014/main" id="{E8DD305E-B1D1-49B3-BEE4-7FA072E93C88}"/>
+                <a16:creationId xmlns:a16="http://schemas.microsoft.com/office/drawing/2014/main" id="{3E42FD95-52DE-4756-8F16-7A25439F7605}"/>
               </a:ext>
             </a:extLst>
           </p:cNvPr>
@@ -2390,7 +2395,7 @@
           <p:cNvPr id="9" name="step-body-01">
             <a:extLst xmlns:a="http://schemas.openxmlformats.org/drawingml/2006/main">
               <a:ext uri="{FF2B5EF4-FFF2-40B4-BE49-F238E27FC236}">
-                <a16:creationId xmlns:a16="http://schemas.microsoft.com/office/drawing/2014/main" id="{35BC8706-E959-4F30-A3DB-AD5228240C94}"/>
+                <a16:creationId xmlns:a16="http://schemas.microsoft.com/office/drawing/2014/main" id="{5B66E9FF-6763-4500-8B3A-2DC338A33A04}"/>
               </a:ext>
             </a:extLst>
           </p:cNvPr>
@@ -2446,7 +2451,7 @@
           <p:cNvPr id="10" name="step-rule-02">
             <a:extLst xmlns:a="http://schemas.openxmlformats.org/drawingml/2006/main">
               <a:ext uri="{FF2B5EF4-FFF2-40B4-BE49-F238E27FC236}">
-                <a16:creationId xmlns:a16="http://schemas.microsoft.com/office/drawing/2014/main" id="{AAB75E73-0EBC-4F18-9AEF-7420E8E22DC9}"/>
+                <a16:creationId xmlns:a16="http://schemas.microsoft.com/office/drawing/2014/main" id="{6393F61E-7F3D-4ADC-827A-FB2D246983D1}"/>
               </a:ext>
             </a:extLst>
           </p:cNvPr>
@@ -2477,7 +2482,7 @@
           <p:cNvPr id="11" name="step-num-02">
             <a:extLst xmlns:a="http://schemas.openxmlformats.org/drawingml/2006/main">
               <a:ext uri="{FF2B5EF4-FFF2-40B4-BE49-F238E27FC236}">
-                <a16:creationId xmlns:a16="http://schemas.microsoft.com/office/drawing/2014/main" id="{C116DC1F-E1B3-46BF-9AA4-456CDE7A230A}"/>
+                <a16:creationId xmlns:a16="http://schemas.microsoft.com/office/drawing/2014/main" id="{C672C3F5-BE71-4F5D-9C57-0EC32D552035}"/>
               </a:ext>
             </a:extLst>
           </p:cNvPr>
@@ -2533,7 +2538,7 @@
           <p:cNvPr id="12" name="step-title-02">
             <a:extLst xmlns:a="http://schemas.openxmlformats.org/drawingml/2006/main">
               <a:ext uri="{FF2B5EF4-FFF2-40B4-BE49-F238E27FC236}">
-                <a16:creationId xmlns:a16="http://schemas.microsoft.com/office/drawing/2014/main" id="{36FE4D3F-C94E-4ED6-96EB-014B7D9B944F}"/>
+                <a16:creationId xmlns:a16="http://schemas.microsoft.com/office/drawing/2014/main" id="{D4F49AF3-840B-4D34-B4C4-0696ACB04094}"/>
               </a:ext>
             </a:extLst>
           </p:cNvPr>
@@ -2589,7 +2594,7 @@
           <p:cNvPr id="13" name="step-body-02">
             <a:extLst xmlns:a="http://schemas.openxmlformats.org/drawingml/2006/main">
               <a:ext uri="{FF2B5EF4-FFF2-40B4-BE49-F238E27FC236}">
-                <a16:creationId xmlns:a16="http://schemas.microsoft.com/office/drawing/2014/main" id="{E31B8AA9-CF3E-4E80-B60A-9AB1F0E2E2C8}"/>
+                <a16:creationId xmlns:a16="http://schemas.microsoft.com/office/drawing/2014/main" id="{D254A547-95B9-45BE-9CC6-B12CF03B3EDF}"/>
               </a:ext>
             </a:extLst>
           </p:cNvPr>
@@ -2645,7 +2650,7 @@
           <p:cNvPr id="14" name="step-rule-03">
             <a:extLst xmlns:a="http://schemas.openxmlformats.org/drawingml/2006/main">
               <a:ext uri="{FF2B5EF4-FFF2-40B4-BE49-F238E27FC236}">
-                <a16:creationId xmlns:a16="http://schemas.microsoft.com/office/drawing/2014/main" id="{A2D90D75-9C0E-4AB2-876E-5675C6F91410}"/>
+                <a16:creationId xmlns:a16="http://schemas.microsoft.com/office/drawing/2014/main" id="{82A9624B-9733-4B47-9507-038FCBE999F7}"/>
               </a:ext>
             </a:extLst>
           </p:cNvPr>
@@ -2676,7 +2681,7 @@
           <p:cNvPr id="15" name="step-num-03">
             <a:extLst xmlns:a="http://schemas.openxmlformats.org/drawingml/2006/main">
               <a:ext uri="{FF2B5EF4-FFF2-40B4-BE49-F238E27FC236}">
-                <a16:creationId xmlns:a16="http://schemas.microsoft.com/office/drawing/2014/main" id="{0C0D7129-1540-48ED-943E-9691DBF3A88B}"/>
+                <a16:creationId xmlns:a16="http://schemas.microsoft.com/office/drawing/2014/main" id="{60AC0CA4-4EA2-429D-AF75-F8CE182389E0}"/>
               </a:ext>
             </a:extLst>
           </p:cNvPr>
@@ -2732,7 +2737,7 @@
           <p:cNvPr id="16" name="step-title-03">
             <a:extLst xmlns:a="http://schemas.openxmlformats.org/drawingml/2006/main">
               <a:ext uri="{FF2B5EF4-FFF2-40B4-BE49-F238E27FC236}">
-                <a16:creationId xmlns:a16="http://schemas.microsoft.com/office/drawing/2014/main" id="{28DE4BC9-E8B4-4E6D-AAF3-D362B5DD1356}"/>
+                <a16:creationId xmlns:a16="http://schemas.microsoft.com/office/drawing/2014/main" id="{2C62E7A4-5768-455D-9267-C72FA86EC4DA}"/>
               </a:ext>
             </a:extLst>
           </p:cNvPr>
@@ -2788,7 +2793,7 @@
           <p:cNvPr id="17" name="step-body-03">
             <a:extLst xmlns:a="http://schemas.openxmlformats.org/drawingml/2006/main">
               <a:ext uri="{FF2B5EF4-FFF2-40B4-BE49-F238E27FC236}">
-                <a16:creationId xmlns:a16="http://schemas.microsoft.com/office/drawing/2014/main" id="{8F0DDDAE-CF08-460F-B38B-BC042C09F200}"/>
+                <a16:creationId xmlns:a16="http://schemas.microsoft.com/office/drawing/2014/main" id="{626D035E-7393-4583-A457-5274DA5653D5}"/>
               </a:ext>
             </a:extLst>
           </p:cNvPr>
@@ -2844,7 +2849,7 @@
           <p:cNvPr id="18" name="step-rule-04">
             <a:extLst xmlns:a="http://schemas.openxmlformats.org/drawingml/2006/main">
               <a:ext uri="{FF2B5EF4-FFF2-40B4-BE49-F238E27FC236}">
-                <a16:creationId xmlns:a16="http://schemas.microsoft.com/office/drawing/2014/main" id="{95D15115-C008-4F32-A892-19ECA89C8C22}"/>
+                <a16:creationId xmlns:a16="http://schemas.microsoft.com/office/drawing/2014/main" id="{48C10781-C012-4194-9C73-F86AA910B474}"/>
               </a:ext>
             </a:extLst>
           </p:cNvPr>
@@ -2875,7 +2880,7 @@
           <p:cNvPr id="19" name="step-num-04">
             <a:extLst xmlns:a="http://schemas.openxmlformats.org/drawingml/2006/main">
               <a:ext uri="{FF2B5EF4-FFF2-40B4-BE49-F238E27FC236}">
-                <a16:creationId xmlns:a16="http://schemas.microsoft.com/office/drawing/2014/main" id="{84551693-742D-4C6D-8165-7A103AD1114E}"/>
+                <a16:creationId xmlns:a16="http://schemas.microsoft.com/office/drawing/2014/main" id="{892DD53C-4990-4EDF-A317-90AE92E0FC06}"/>
               </a:ext>
             </a:extLst>
           </p:cNvPr>
@@ -2931,7 +2936,7 @@
           <p:cNvPr id="20" name="step-title-04">
             <a:extLst xmlns:a="http://schemas.openxmlformats.org/drawingml/2006/main">
               <a:ext uri="{FF2B5EF4-FFF2-40B4-BE49-F238E27FC236}">
-                <a16:creationId xmlns:a16="http://schemas.microsoft.com/office/drawing/2014/main" id="{6673C75D-E8DB-4785-A84C-5E3D663AFA5C}"/>
+                <a16:creationId xmlns:a16="http://schemas.microsoft.com/office/drawing/2014/main" id="{11FED2C3-DC34-4300-8034-AF9B340451F2}"/>
               </a:ext>
             </a:extLst>
           </p:cNvPr>
@@ -2987,7 +2992,7 @@
           <p:cNvPr id="21" name="step-body-04">
             <a:extLst xmlns:a="http://schemas.openxmlformats.org/drawingml/2006/main">
               <a:ext uri="{FF2B5EF4-FFF2-40B4-BE49-F238E27FC236}">
-                <a16:creationId xmlns:a16="http://schemas.microsoft.com/office/drawing/2014/main" id="{2550ADC8-46D8-4F8D-B031-9AA0BB461851}"/>
+                <a16:creationId xmlns:a16="http://schemas.microsoft.com/office/drawing/2014/main" id="{F711894E-1325-4B09-9F6C-E75BD0E4C343}"/>
               </a:ext>
             </a:extLst>
           </p:cNvPr>
@@ -3041,7 +3046,7 @@
     </p:spTree>
     <p:extLst>
       <p:ext uri="{BB962C8B-B14F-4D97-AF65-F5344CB8AC3E}">
-        <p14:creationId xmlns:p14="http://schemas.microsoft.com/office/powerpoint/2010/main" val="1058300998"/>
+        <p14:creationId xmlns:p14="http://schemas.microsoft.com/office/powerpoint/2010/main" val="1030328321"/>
       </p:ext>
     </p:extLst>
   </p:cSld>
@@ -3072,7 +3077,7 @@
           <p:cNvPr id="19" name="eyebrow-3">
             <a:extLst xmlns:a="http://schemas.openxmlformats.org/drawingml/2006/main">
               <a:ext uri="{FF2B5EF4-FFF2-40B4-BE49-F238E27FC236}">
-                <a16:creationId xmlns:a16="http://schemas.microsoft.com/office/drawing/2014/main" id="{B99AEC18-167C-4E21-8637-B56EC257F60C}"/>
+                <a16:creationId xmlns:a16="http://schemas.microsoft.com/office/drawing/2014/main" id="{831E3F62-FFD3-4284-AF67-D10E46CCCE09}"/>
               </a:ext>
             </a:extLst>
           </p:cNvPr>
@@ -3128,7 +3133,7 @@
           <p:cNvPr id="2" name="title-3">
             <a:extLst xmlns:a="http://schemas.openxmlformats.org/drawingml/2006/main">
               <a:ext uri="{FF2B5EF4-FFF2-40B4-BE49-F238E27FC236}">
-                <a16:creationId xmlns:a16="http://schemas.microsoft.com/office/drawing/2014/main" id="{944E448E-2DE8-4B3C-9C17-83DA2AAAFA92}"/>
+                <a16:creationId xmlns:a16="http://schemas.microsoft.com/office/drawing/2014/main" id="{E742280C-E55A-4F4D-88E2-9063CAD41E89}"/>
               </a:ext>
             </a:extLst>
           </p:cNvPr>
@@ -3184,7 +3189,7 @@
           <p:cNvPr id="3" name="slide-number-3">
             <a:extLst xmlns:a="http://schemas.openxmlformats.org/drawingml/2006/main">
               <a:ext uri="{FF2B5EF4-FFF2-40B4-BE49-F238E27FC236}">
-                <a16:creationId xmlns:a16="http://schemas.microsoft.com/office/drawing/2014/main" id="{1EE2AA42-3441-4CBE-85C1-AA02F2F9517C}"/>
+                <a16:creationId xmlns:a16="http://schemas.microsoft.com/office/drawing/2014/main" id="{08B971CB-9101-40C1-A241-FDD89C72E639}"/>
               </a:ext>
             </a:extLst>
           </p:cNvPr>
@@ -3240,7 +3245,7 @@
           <p:cNvPr id="4" name="architecture-line">
             <a:extLst xmlns:a="http://schemas.openxmlformats.org/drawingml/2006/main">
               <a:ext uri="{FF2B5EF4-FFF2-40B4-BE49-F238E27FC236}">
-                <a16:creationId xmlns:a16="http://schemas.microsoft.com/office/drawing/2014/main" id="{844D54C0-FD36-46D1-8263-BB3C40259A79}"/>
+                <a16:creationId xmlns:a16="http://schemas.microsoft.com/office/drawing/2014/main" id="{C46E2739-40EF-4F8F-8122-DC9673029C63}"/>
               </a:ext>
             </a:extLst>
           </p:cNvPr>
@@ -3271,7 +3276,7 @@
           <p:cNvPr id="5" name="architecture-node-0">
             <a:extLst xmlns:a="http://schemas.openxmlformats.org/drawingml/2006/main">
               <a:ext uri="{FF2B5EF4-FFF2-40B4-BE49-F238E27FC236}">
-                <a16:creationId xmlns:a16="http://schemas.microsoft.com/office/drawing/2014/main" id="{AAAEB04E-D40F-45B0-BCCE-D90AA239BDD0}"/>
+                <a16:creationId xmlns:a16="http://schemas.microsoft.com/office/drawing/2014/main" id="{BEC55C89-06C7-496D-AE87-1E6FC7E21695}"/>
               </a:ext>
             </a:extLst>
           </p:cNvPr>
@@ -3304,7 +3309,7 @@
           <p:cNvPr id="6" name="architecture-label-0">
             <a:extLst xmlns:a="http://schemas.openxmlformats.org/drawingml/2006/main">
               <a:ext uri="{FF2B5EF4-FFF2-40B4-BE49-F238E27FC236}">
-                <a16:creationId xmlns:a16="http://schemas.microsoft.com/office/drawing/2014/main" id="{F965F3E9-61A1-498B-8E2C-DA865C5458CF}"/>
+                <a16:creationId xmlns:a16="http://schemas.microsoft.com/office/drawing/2014/main" id="{A373682F-178E-4E9C-A6D5-411F05D746C2}"/>
               </a:ext>
             </a:extLst>
           </p:cNvPr>
@@ -3360,7 +3365,7 @@
           <p:cNvPr id="7" name="architecture-title-0">
             <a:extLst xmlns:a="http://schemas.openxmlformats.org/drawingml/2006/main">
               <a:ext uri="{FF2B5EF4-FFF2-40B4-BE49-F238E27FC236}">
-                <a16:creationId xmlns:a16="http://schemas.microsoft.com/office/drawing/2014/main" id="{9BC22A2D-B431-4BB5-80D0-95F210E03DCD}"/>
+                <a16:creationId xmlns:a16="http://schemas.microsoft.com/office/drawing/2014/main" id="{3503F473-7DE2-4D29-AE03-F5CF23575453}"/>
               </a:ext>
             </a:extLst>
           </p:cNvPr>
@@ -3416,7 +3421,7 @@
           <p:cNvPr id="8" name="architecture-body-0">
             <a:extLst xmlns:a="http://schemas.openxmlformats.org/drawingml/2006/main">
               <a:ext uri="{FF2B5EF4-FFF2-40B4-BE49-F238E27FC236}">
-                <a16:creationId xmlns:a16="http://schemas.microsoft.com/office/drawing/2014/main" id="{9FEAC8B0-D272-46D5-81D8-469FB290D1D1}"/>
+                <a16:creationId xmlns:a16="http://schemas.microsoft.com/office/drawing/2014/main" id="{3A08C639-17AC-4398-868B-47412BE4DF23}"/>
               </a:ext>
             </a:extLst>
           </p:cNvPr>
@@ -3472,7 +3477,7 @@
           <p:cNvPr id="9" name="architecture-node-1">
             <a:extLst xmlns:a="http://schemas.openxmlformats.org/drawingml/2006/main">
               <a:ext uri="{FF2B5EF4-FFF2-40B4-BE49-F238E27FC236}">
-                <a16:creationId xmlns:a16="http://schemas.microsoft.com/office/drawing/2014/main" id="{606A9E18-FB32-4F28-A050-6221EB78CC30}"/>
+                <a16:creationId xmlns:a16="http://schemas.microsoft.com/office/drawing/2014/main" id="{AA4F846E-D2F1-4550-954A-F1EC720C2B9A}"/>
               </a:ext>
             </a:extLst>
           </p:cNvPr>
@@ -3505,7 +3510,7 @@
           <p:cNvPr id="10" name="architecture-label-1">
             <a:extLst xmlns:a="http://schemas.openxmlformats.org/drawingml/2006/main">
               <a:ext uri="{FF2B5EF4-FFF2-40B4-BE49-F238E27FC236}">
-                <a16:creationId xmlns:a16="http://schemas.microsoft.com/office/drawing/2014/main" id="{70907993-9039-4C4C-AD25-45A835E29BEC}"/>
+                <a16:creationId xmlns:a16="http://schemas.microsoft.com/office/drawing/2014/main" id="{976F69E1-63AC-4564-BD95-3A728A4F1BD8}"/>
               </a:ext>
             </a:extLst>
           </p:cNvPr>
@@ -3561,7 +3566,7 @@
           <p:cNvPr id="11" name="architecture-title-1">
             <a:extLst xmlns:a="http://schemas.openxmlformats.org/drawingml/2006/main">
               <a:ext uri="{FF2B5EF4-FFF2-40B4-BE49-F238E27FC236}">
-                <a16:creationId xmlns:a16="http://schemas.microsoft.com/office/drawing/2014/main" id="{B0458B90-7949-4506-B589-174DBA4E1B78}"/>
+                <a16:creationId xmlns:a16="http://schemas.microsoft.com/office/drawing/2014/main" id="{5F8FE413-B642-46B0-A216-104D6A24C46B}"/>
               </a:ext>
             </a:extLst>
           </p:cNvPr>
@@ -3617,7 +3622,7 @@
           <p:cNvPr id="12" name="architecture-body-1">
             <a:extLst xmlns:a="http://schemas.openxmlformats.org/drawingml/2006/main">
               <a:ext uri="{FF2B5EF4-FFF2-40B4-BE49-F238E27FC236}">
-                <a16:creationId xmlns:a16="http://schemas.microsoft.com/office/drawing/2014/main" id="{BAD96E52-FAB4-4F1A-B858-7E4AF2FA590F}"/>
+                <a16:creationId xmlns:a16="http://schemas.microsoft.com/office/drawing/2014/main" id="{33F5AD9D-C0B6-4CEC-AFBF-CC4B377FE79D}"/>
               </a:ext>
             </a:extLst>
           </p:cNvPr>
@@ -3673,7 +3678,7 @@
           <p:cNvPr id="13" name="architecture-node-2">
             <a:extLst xmlns:a="http://schemas.openxmlformats.org/drawingml/2006/main">
               <a:ext uri="{FF2B5EF4-FFF2-40B4-BE49-F238E27FC236}">
-                <a16:creationId xmlns:a16="http://schemas.microsoft.com/office/drawing/2014/main" id="{D10A854A-FDC0-4DEB-8D27-86E2F3AFE888}"/>
+                <a16:creationId xmlns:a16="http://schemas.microsoft.com/office/drawing/2014/main" id="{04710B81-424E-4511-922B-04903C0AEE5F}"/>
               </a:ext>
             </a:extLst>
           </p:cNvPr>
@@ -3706,7 +3711,7 @@
           <p:cNvPr id="14" name="architecture-label-2">
             <a:extLst xmlns:a="http://schemas.openxmlformats.org/drawingml/2006/main">
               <a:ext uri="{FF2B5EF4-FFF2-40B4-BE49-F238E27FC236}">
-                <a16:creationId xmlns:a16="http://schemas.microsoft.com/office/drawing/2014/main" id="{3486B1CB-4A87-463F-9508-912D257168B8}"/>
+                <a16:creationId xmlns:a16="http://schemas.microsoft.com/office/drawing/2014/main" id="{54A49E26-DD78-4B1D-AA24-D22936591851}"/>
               </a:ext>
             </a:extLst>
           </p:cNvPr>
@@ -3762,7 +3767,7 @@
           <p:cNvPr id="15" name="architecture-title-2">
             <a:extLst xmlns:a="http://schemas.openxmlformats.org/drawingml/2006/main">
               <a:ext uri="{FF2B5EF4-FFF2-40B4-BE49-F238E27FC236}">
-                <a16:creationId xmlns:a16="http://schemas.microsoft.com/office/drawing/2014/main" id="{26104529-149C-4F3D-A782-405F238A65BF}"/>
+                <a16:creationId xmlns:a16="http://schemas.microsoft.com/office/drawing/2014/main" id="{598F27A7-6418-495B-9526-F93227C7C0EB}"/>
               </a:ext>
             </a:extLst>
           </p:cNvPr>
@@ -3818,7 +3823,7 @@
           <p:cNvPr id="16" name="architecture-body-2">
             <a:extLst xmlns:a="http://schemas.openxmlformats.org/drawingml/2006/main">
               <a:ext uri="{FF2B5EF4-FFF2-40B4-BE49-F238E27FC236}">
-                <a16:creationId xmlns:a16="http://schemas.microsoft.com/office/drawing/2014/main" id="{67B1D479-9B4A-4061-B20A-5FFC0A2BC8B0}"/>
+                <a16:creationId xmlns:a16="http://schemas.microsoft.com/office/drawing/2014/main" id="{F4273FAD-F42C-46FF-9F92-40EAF0A142E6}"/>
               </a:ext>
             </a:extLst>
           </p:cNvPr>
@@ -3874,7 +3879,7 @@
           <p:cNvPr id="17" name="boundary-rail">
             <a:extLst xmlns:a="http://schemas.openxmlformats.org/drawingml/2006/main">
               <a:ext uri="{FF2B5EF4-FFF2-40B4-BE49-F238E27FC236}">
-                <a16:creationId xmlns:a16="http://schemas.microsoft.com/office/drawing/2014/main" id="{A5ABE425-8C7F-4E18-B4FD-B7DB23966E44}"/>
+                <a16:creationId xmlns:a16="http://schemas.microsoft.com/office/drawing/2014/main" id="{96C5B4E9-7F54-4EF2-ADE7-494E7AD7DF44}"/>
               </a:ext>
             </a:extLst>
           </p:cNvPr>
@@ -3905,7 +3910,7 @@
           <p:cNvPr id="18" name="boundary-copy">
             <a:extLst xmlns:a="http://schemas.openxmlformats.org/drawingml/2006/main">
               <a:ext uri="{FF2B5EF4-FFF2-40B4-BE49-F238E27FC236}">
-                <a16:creationId xmlns:a16="http://schemas.microsoft.com/office/drawing/2014/main" id="{615D51DC-ECB2-4BA2-B091-F740F2417126}"/>
+                <a16:creationId xmlns:a16="http://schemas.microsoft.com/office/drawing/2014/main" id="{64E62DD9-77B9-4693-A8F7-43A58129B50E}"/>
               </a:ext>
             </a:extLst>
           </p:cNvPr>
@@ -3959,7 +3964,7 @@
     </p:spTree>
     <p:extLst>
       <p:ext uri="{BB962C8B-B14F-4D97-AF65-F5344CB8AC3E}">
-        <p14:creationId xmlns:p14="http://schemas.microsoft.com/office/powerpoint/2010/main" val="1820434138"/>
+        <p14:creationId xmlns:p14="http://schemas.microsoft.com/office/powerpoint/2010/main" val="269668447"/>
       </p:ext>
     </p:extLst>
   </p:cSld>
@@ -3990,7 +3995,7 @@
           <p:cNvPr id="20" name="eyebrow-4">
             <a:extLst xmlns:a="http://schemas.openxmlformats.org/drawingml/2006/main">
               <a:ext uri="{FF2B5EF4-FFF2-40B4-BE49-F238E27FC236}">
-                <a16:creationId xmlns:a16="http://schemas.microsoft.com/office/drawing/2014/main" id="{C501B3D1-9002-4044-81EB-7CCCC1F8D716}"/>
+                <a16:creationId xmlns:a16="http://schemas.microsoft.com/office/drawing/2014/main" id="{096A4BA6-43E1-4BAF-8A1D-28585F4CB164}"/>
               </a:ext>
             </a:extLst>
           </p:cNvPr>
@@ -4046,7 +4051,7 @@
           <p:cNvPr id="2" name="title-4">
             <a:extLst xmlns:a="http://schemas.openxmlformats.org/drawingml/2006/main">
               <a:ext uri="{FF2B5EF4-FFF2-40B4-BE49-F238E27FC236}">
-                <a16:creationId xmlns:a16="http://schemas.microsoft.com/office/drawing/2014/main" id="{2B8F6B99-D276-4285-9FF4-B85F44B6797A}"/>
+                <a16:creationId xmlns:a16="http://schemas.microsoft.com/office/drawing/2014/main" id="{BDA3411F-EE3C-412C-BEA5-7345AF602C78}"/>
               </a:ext>
             </a:extLst>
           </p:cNvPr>
@@ -4102,7 +4107,7 @@
           <p:cNvPr id="3" name="slide-number-4">
             <a:extLst xmlns:a="http://schemas.openxmlformats.org/drawingml/2006/main">
               <a:ext uri="{FF2B5EF4-FFF2-40B4-BE49-F238E27FC236}">
-                <a16:creationId xmlns:a16="http://schemas.microsoft.com/office/drawing/2014/main" id="{FBD52269-CBE8-47EC-860F-6CE36746893D}"/>
+                <a16:creationId xmlns:a16="http://schemas.microsoft.com/office/drawing/2014/main" id="{B15D7723-5790-465C-B291-6A596B7FD2A6}"/>
               </a:ext>
             </a:extLst>
           </p:cNvPr>
@@ -4158,7 +4163,7 @@
           <p:cNvPr id="4" name="safety-intro">
             <a:extLst xmlns:a="http://schemas.openxmlformats.org/drawingml/2006/main">
               <a:ext uri="{FF2B5EF4-FFF2-40B4-BE49-F238E27FC236}">
-                <a16:creationId xmlns:a16="http://schemas.microsoft.com/office/drawing/2014/main" id="{FA3304EB-915E-4249-B82C-D50A5BB5E884}"/>
+                <a16:creationId xmlns:a16="http://schemas.microsoft.com/office/drawing/2014/main" id="{3F862517-9723-4BCC-8688-CE7CC3825357}"/>
               </a:ext>
             </a:extLst>
           </p:cNvPr>
@@ -4214,7 +4219,7 @@
           <p:cNvPr id="5" name="metric-panel-1">
             <a:extLst xmlns:a="http://schemas.openxmlformats.org/drawingml/2006/main">
               <a:ext uri="{FF2B5EF4-FFF2-40B4-BE49-F238E27FC236}">
-                <a16:creationId xmlns:a16="http://schemas.microsoft.com/office/drawing/2014/main" id="{08313760-6B1F-46BB-A3CA-844C7AD5769A}"/>
+                <a16:creationId xmlns:a16="http://schemas.microsoft.com/office/drawing/2014/main" id="{07593434-CB21-4B23-81FD-91CFC636213A}"/>
               </a:ext>
             </a:extLst>
           </p:cNvPr>
@@ -4245,7 +4250,7 @@
           <p:cNvPr id="6" name="metric-accent-1">
             <a:extLst xmlns:a="http://schemas.openxmlformats.org/drawingml/2006/main">
               <a:ext uri="{FF2B5EF4-FFF2-40B4-BE49-F238E27FC236}">
-                <a16:creationId xmlns:a16="http://schemas.microsoft.com/office/drawing/2014/main" id="{5A46092C-A699-44AE-A5FB-5454A8FC80D1}"/>
+                <a16:creationId xmlns:a16="http://schemas.microsoft.com/office/drawing/2014/main" id="{3AE40302-09DB-457A-BEB9-915A12C3A2CE}"/>
               </a:ext>
             </a:extLst>
           </p:cNvPr>
@@ -4276,7 +4281,7 @@
           <p:cNvPr id="7" name="metric-stat-1">
             <a:extLst xmlns:a="http://schemas.openxmlformats.org/drawingml/2006/main">
               <a:ext uri="{FF2B5EF4-FFF2-40B4-BE49-F238E27FC236}">
-                <a16:creationId xmlns:a16="http://schemas.microsoft.com/office/drawing/2014/main" id="{C56E2942-348A-4581-9673-E371341E1DAA}"/>
+                <a16:creationId xmlns:a16="http://schemas.microsoft.com/office/drawing/2014/main" id="{FEA0C876-25C3-41DA-88AC-2B1F97B2B5AB}"/>
               </a:ext>
             </a:extLst>
           </p:cNvPr>
@@ -4332,7 +4337,7 @@
           <p:cNvPr id="8" name="metric-label-1">
             <a:extLst xmlns:a="http://schemas.openxmlformats.org/drawingml/2006/main">
               <a:ext uri="{FF2B5EF4-FFF2-40B4-BE49-F238E27FC236}">
-                <a16:creationId xmlns:a16="http://schemas.microsoft.com/office/drawing/2014/main" id="{9B24E898-24A8-40CA-88CD-88C9049A751D}"/>
+                <a16:creationId xmlns:a16="http://schemas.microsoft.com/office/drawing/2014/main" id="{5C186A85-07AC-4595-A5F8-32B3C166DB83}"/>
               </a:ext>
             </a:extLst>
           </p:cNvPr>
@@ -4388,7 +4393,7 @@
           <p:cNvPr id="9" name="metric-detail-1">
             <a:extLst xmlns:a="http://schemas.openxmlformats.org/drawingml/2006/main">
               <a:ext uri="{FF2B5EF4-FFF2-40B4-BE49-F238E27FC236}">
-                <a16:creationId xmlns:a16="http://schemas.microsoft.com/office/drawing/2014/main" id="{3A12C501-F487-4FDF-ACED-67C430D20907}"/>
+                <a16:creationId xmlns:a16="http://schemas.microsoft.com/office/drawing/2014/main" id="{25D88AA2-4D52-4683-938D-67F8D9D050DD}"/>
               </a:ext>
             </a:extLst>
           </p:cNvPr>
@@ -4444,7 +4449,7 @@
           <p:cNvPr id="10" name="metric-panel-2">
             <a:extLst xmlns:a="http://schemas.openxmlformats.org/drawingml/2006/main">
               <a:ext uri="{FF2B5EF4-FFF2-40B4-BE49-F238E27FC236}">
-                <a16:creationId xmlns:a16="http://schemas.microsoft.com/office/drawing/2014/main" id="{A16C697E-9A6A-46E0-85A5-DCF2B2662A4B}"/>
+                <a16:creationId xmlns:a16="http://schemas.microsoft.com/office/drawing/2014/main" id="{FA35F1B3-6FEA-4B1F-975D-B3CC720986BE}"/>
               </a:ext>
             </a:extLst>
           </p:cNvPr>
@@ -4475,7 +4480,7 @@
           <p:cNvPr id="11" name="metric-accent-2">
             <a:extLst xmlns:a="http://schemas.openxmlformats.org/drawingml/2006/main">
               <a:ext uri="{FF2B5EF4-FFF2-40B4-BE49-F238E27FC236}">
-                <a16:creationId xmlns:a16="http://schemas.microsoft.com/office/drawing/2014/main" id="{60A670C4-FF9E-4426-8BA6-D2A6891766E2}"/>
+                <a16:creationId xmlns:a16="http://schemas.microsoft.com/office/drawing/2014/main" id="{7C5E08B0-3E6C-404B-A2D1-83A14F49682B}"/>
               </a:ext>
             </a:extLst>
           </p:cNvPr>
@@ -4506,7 +4511,7 @@
           <p:cNvPr id="12" name="metric-stat-2">
             <a:extLst xmlns:a="http://schemas.openxmlformats.org/drawingml/2006/main">
               <a:ext uri="{FF2B5EF4-FFF2-40B4-BE49-F238E27FC236}">
-                <a16:creationId xmlns:a16="http://schemas.microsoft.com/office/drawing/2014/main" id="{67D78602-96C3-4295-AAB9-B5682B6DBC21}"/>
+                <a16:creationId xmlns:a16="http://schemas.microsoft.com/office/drawing/2014/main" id="{9DEC49D2-0D17-4412-AF2F-2CDAF83A206F}"/>
               </a:ext>
             </a:extLst>
           </p:cNvPr>
@@ -4562,7 +4567,7 @@
           <p:cNvPr id="13" name="metric-label-2">
             <a:extLst xmlns:a="http://schemas.openxmlformats.org/drawingml/2006/main">
               <a:ext uri="{FF2B5EF4-FFF2-40B4-BE49-F238E27FC236}">
-                <a16:creationId xmlns:a16="http://schemas.microsoft.com/office/drawing/2014/main" id="{5695E72E-00F1-40F4-8608-067A899AE54D}"/>
+                <a16:creationId xmlns:a16="http://schemas.microsoft.com/office/drawing/2014/main" id="{A3FC3709-C2A2-4B12-8054-7D1A28387AEF}"/>
               </a:ext>
             </a:extLst>
           </p:cNvPr>
@@ -4618,7 +4623,7 @@
           <p:cNvPr id="14" name="metric-detail-2">
             <a:extLst xmlns:a="http://schemas.openxmlformats.org/drawingml/2006/main">
               <a:ext uri="{FF2B5EF4-FFF2-40B4-BE49-F238E27FC236}">
-                <a16:creationId xmlns:a16="http://schemas.microsoft.com/office/drawing/2014/main" id="{4BE8EE71-3372-4E8A-A46D-97F90796DF81}"/>
+                <a16:creationId xmlns:a16="http://schemas.microsoft.com/office/drawing/2014/main" id="{DDD4976B-725F-45AB-A308-18BF74A1C117}"/>
               </a:ext>
             </a:extLst>
           </p:cNvPr>
@@ -4674,7 +4679,7 @@
           <p:cNvPr id="15" name="metric-panel-3">
             <a:extLst xmlns:a="http://schemas.openxmlformats.org/drawingml/2006/main">
               <a:ext uri="{FF2B5EF4-FFF2-40B4-BE49-F238E27FC236}">
-                <a16:creationId xmlns:a16="http://schemas.microsoft.com/office/drawing/2014/main" id="{5CEBB96B-F56E-4F0E-BE92-6A57771FE3BE}"/>
+                <a16:creationId xmlns:a16="http://schemas.microsoft.com/office/drawing/2014/main" id="{C582D820-5F1E-472B-8A68-7D6675B2A15A}"/>
               </a:ext>
             </a:extLst>
           </p:cNvPr>
@@ -4705,7 +4710,7 @@
           <p:cNvPr id="16" name="metric-accent-3">
             <a:extLst xmlns:a="http://schemas.openxmlformats.org/drawingml/2006/main">
               <a:ext uri="{FF2B5EF4-FFF2-40B4-BE49-F238E27FC236}">
-                <a16:creationId xmlns:a16="http://schemas.microsoft.com/office/drawing/2014/main" id="{3F1041A8-32CF-4E69-9E1C-B0125E7B8279}"/>
+                <a16:creationId xmlns:a16="http://schemas.microsoft.com/office/drawing/2014/main" id="{C89BD310-A8AF-4368-94BA-82ED6E4777ED}"/>
               </a:ext>
             </a:extLst>
           </p:cNvPr>
@@ -4736,7 +4741,7 @@
           <p:cNvPr id="17" name="metric-stat-3">
             <a:extLst xmlns:a="http://schemas.openxmlformats.org/drawingml/2006/main">
               <a:ext uri="{FF2B5EF4-FFF2-40B4-BE49-F238E27FC236}">
-                <a16:creationId xmlns:a16="http://schemas.microsoft.com/office/drawing/2014/main" id="{04CF980C-8934-433E-9E55-4E8039EF7E47}"/>
+                <a16:creationId xmlns:a16="http://schemas.microsoft.com/office/drawing/2014/main" id="{245DC855-948D-4472-BE46-D8C661C93CE4}"/>
               </a:ext>
             </a:extLst>
           </p:cNvPr>
@@ -4792,7 +4797,7 @@
           <p:cNvPr id="18" name="metric-label-3">
             <a:extLst xmlns:a="http://schemas.openxmlformats.org/drawingml/2006/main">
               <a:ext uri="{FF2B5EF4-FFF2-40B4-BE49-F238E27FC236}">
-                <a16:creationId xmlns:a16="http://schemas.microsoft.com/office/drawing/2014/main" id="{6A744F61-454A-4014-9710-3315FF32AB28}"/>
+                <a16:creationId xmlns:a16="http://schemas.microsoft.com/office/drawing/2014/main" id="{40C601D0-90B6-453E-8796-306778451775}"/>
               </a:ext>
             </a:extLst>
           </p:cNvPr>
@@ -4848,7 +4853,7 @@
           <p:cNvPr id="19" name="metric-detail-3">
             <a:extLst xmlns:a="http://schemas.openxmlformats.org/drawingml/2006/main">
               <a:ext uri="{FF2B5EF4-FFF2-40B4-BE49-F238E27FC236}">
-                <a16:creationId xmlns:a16="http://schemas.microsoft.com/office/drawing/2014/main" id="{B69349F6-4D48-4AA5-A4ED-88902658D1FF}"/>
+                <a16:creationId xmlns:a16="http://schemas.microsoft.com/office/drawing/2014/main" id="{60C24E94-2D76-4433-8BC5-FCFD746ADB2E}"/>
               </a:ext>
             </a:extLst>
           </p:cNvPr>
@@ -4902,7 +4907,7 @@
     </p:spTree>
     <p:extLst>
       <p:ext uri="{BB962C8B-B14F-4D97-AF65-F5344CB8AC3E}">
-        <p14:creationId xmlns:p14="http://schemas.microsoft.com/office/powerpoint/2010/main" val="213713342"/>
+        <p14:creationId xmlns:p14="http://schemas.microsoft.com/office/powerpoint/2010/main" val="207311938"/>
       </p:ext>
     </p:extLst>
   </p:cSld>
@@ -4930,10 +4935,10 @@
       </p:grpSpPr>
       <p:sp>
         <p:nvSpPr>
-          <p:cNvPr id="21" name="eyebrow-5">
-            <a:extLst xmlns:a="http://schemas.openxmlformats.org/drawingml/2006/main">
-              <a:ext uri="{FF2B5EF4-FFF2-40B4-BE49-F238E27FC236}">
-                <a16:creationId xmlns:a16="http://schemas.microsoft.com/office/drawing/2014/main" id="{B8380DC9-1B17-4694-977C-CED1EA8E5E0A}"/>
+          <p:cNvPr id="22" name="eyebrow-5">
+            <a:extLst xmlns:a="http://schemas.openxmlformats.org/drawingml/2006/main">
+              <a:ext uri="{FF2B5EF4-FFF2-40B4-BE49-F238E27FC236}">
+                <a16:creationId xmlns:a16="http://schemas.microsoft.com/office/drawing/2014/main" id="{8E899B7A-1E78-42A6-BB3F-7F679765068B}"/>
               </a:ext>
             </a:extLst>
           </p:cNvPr>
@@ -4989,7 +4994,7 @@
           <p:cNvPr id="2" name="title-5">
             <a:extLst xmlns:a="http://schemas.openxmlformats.org/drawingml/2006/main">
               <a:ext uri="{FF2B5EF4-FFF2-40B4-BE49-F238E27FC236}">
-                <a16:creationId xmlns:a16="http://schemas.microsoft.com/office/drawing/2014/main" id="{8D25BEC2-3800-42CB-B0CF-218ECA10527D}"/>
+                <a16:creationId xmlns:a16="http://schemas.microsoft.com/office/drawing/2014/main" id="{4E8B294D-40F4-4995-B88D-2F696B4AB9F6}"/>
               </a:ext>
             </a:extLst>
           </p:cNvPr>
@@ -5035,7 +5040,7 @@
                 <a:ea typeface="Helvetica Neue"/>
                 <a:cs typeface="Helvetica Neue"/>
               </a:rPr>
-              <a:t>The release shows evidence, including why it refused risk.</a:t>
+              <a:t>A live, read-only trail from agent state to account equity.</a:t>
             </a:r>
           </a:p>
         </p:txBody>
@@ -5045,7 +5050,7 @@
           <p:cNvPr id="3" name="slide-number-5">
             <a:extLst xmlns:a="http://schemas.openxmlformats.org/drawingml/2006/main">
               <a:ext uri="{FF2B5EF4-FFF2-40B4-BE49-F238E27FC236}">
-                <a16:creationId xmlns:a16="http://schemas.microsoft.com/office/drawing/2014/main" id="{41260F2D-B55C-45B0-AF9B-AA21B5F99B00}"/>
+                <a16:creationId xmlns:a16="http://schemas.microsoft.com/office/drawing/2014/main" id="{7C7A1E9F-A19A-48E3-BF47-D1B4DD566582}"/>
               </a:ext>
             </a:extLst>
           </p:cNvPr>
@@ -5098,78 +5103,78 @@
       </p:sp>
       <p:sp>
         <p:nvSpPr>
-          <p:cNvPr id="4" name="evidence-intro">
-            <a:extLst xmlns:a="http://schemas.openxmlformats.org/drawingml/2006/main">
-              <a:ext uri="{FF2B5EF4-FFF2-40B4-BE49-F238E27FC236}">
-                <a16:creationId xmlns:a16="http://schemas.microsoft.com/office/drawing/2014/main" id="{71C5FF19-436E-46CD-B60A-4E077BE77E1B}"/>
-              </a:ext>
-            </a:extLst>
-          </p:cNvPr>
-          <p:cNvSpPr>
-            <a:spLocks xmlns:a="http://schemas.openxmlformats.org/drawingml/2006/main" noGrp="1"/>
-          </p:cNvSpPr>
-          <p:nvPr/>
-        </p:nvSpPr>
-        <p:spPr>
-          <a:xfrm xmlns:a="http://schemas.openxmlformats.org/drawingml/2006/main">
-            <a:off x="400050" y="1485900"/>
-            <a:ext cx="11391900" cy="723900"/>
-          </a:xfrm>
-          <a:prstGeom xmlns:a="http://schemas.openxmlformats.org/drawingml/2006/main" prst="rect">
-            <a:avLst/>
-          </a:prstGeom>
-          <a:noFill xmlns:a="http://schemas.openxmlformats.org/drawingml/2006/main"/>
-          <a:ln xmlns:a="http://schemas.openxmlformats.org/drawingml/2006/main" w="0">
-            <a:noFill/>
-            <a:prstDash val="solid"/>
-          </a:ln>
-        </p:spPr>
-        <p:txBody>
-          <a:bodyPr xmlns:a="http://schemas.openxmlformats.org/drawingml/2006/main"/>
-          <a:lstStyle xmlns:a="http://schemas.openxmlformats.org/drawingml/2006/main"/>
-          <a:p xmlns:a="http://schemas.openxmlformats.org/drawingml/2006/main">
-            <a:pPr>
-              <a:defRPr sz="1650">
-                <a:solidFill>
-                  <a:srgbClr val="526071"/>
-                </a:solidFill>
-                <a:latin typeface="Helvetica Neue"/>
-                <a:ea typeface="Helvetica Neue"/>
-                <a:cs typeface="Helvetica Neue"/>
-              </a:defRPr>
-            </a:pPr>
-            <a:r>
-              <a:rPr sz="1650">
-                <a:solidFill>
-                  <a:srgbClr val="526071"/>
-                </a:solidFill>
-                <a:latin typeface="Helvetica Neue"/>
-                <a:ea typeface="Helvetica Neue"/>
-                <a:cs typeface="Helvetica Neue"/>
-              </a:rPr>
-              <a:t>The submission reports broker-reconciled paper results only. It does not turn replay output, simulated fills, or a no-trade decision into a profitability claim.</a:t>
-            </a:r>
-          </a:p>
-        </p:txBody>
-      </p:sp>
-      <p:sp>
-        <p:nvSpPr>
-          <p:cNvPr id="5" name="metric-panel-4">
-            <a:extLst xmlns:a="http://schemas.openxmlformats.org/drawingml/2006/main">
-              <a:ext uri="{FF2B5EF4-FFF2-40B4-BE49-F238E27FC236}">
-                <a16:creationId xmlns:a16="http://schemas.microsoft.com/office/drawing/2014/main" id="{05518AD3-8D62-473C-8CFA-964973961D82}"/>
-              </a:ext>
-            </a:extLst>
-          </p:cNvPr>
-          <p:cNvSpPr>
-            <a:spLocks xmlns:a="http://schemas.openxmlformats.org/drawingml/2006/main" noGrp="1"/>
-          </p:cNvSpPr>
-          <p:nvPr/>
-        </p:nvSpPr>
-        <p:spPr>
-          <a:xfrm xmlns:a="http://schemas.openxmlformats.org/drawingml/2006/main">
-            <a:off x="400050" y="2800350"/>
-            <a:ext cx="3333750" cy="2857500"/>
+          <p:cNvPr id="4" name="dashboard-frame">
+            <a:extLst xmlns:a="http://schemas.openxmlformats.org/drawingml/2006/main">
+              <a:ext uri="{FF2B5EF4-FFF2-40B4-BE49-F238E27FC236}">
+                <a16:creationId xmlns:a16="http://schemas.microsoft.com/office/drawing/2014/main" id="{7624F0CD-1E05-4C30-8A90-9F12702A9AC8}"/>
+              </a:ext>
+            </a:extLst>
+          </p:cNvPr>
+          <p:cNvSpPr>
+            <a:spLocks xmlns:a="http://schemas.openxmlformats.org/drawingml/2006/main" noGrp="1"/>
+          </p:cNvSpPr>
+          <p:nvPr/>
+        </p:nvSpPr>
+        <p:spPr>
+          <a:xfrm xmlns:a="http://schemas.openxmlformats.org/drawingml/2006/main">
+            <a:off x="400050" y="1581150"/>
+            <a:ext cx="7239000" cy="4533900"/>
+          </a:xfrm>
+          <a:prstGeom xmlns:a="http://schemas.openxmlformats.org/drawingml/2006/main" prst="rect">
+            <a:avLst/>
+          </a:prstGeom>
+          <a:solidFill xmlns:a="http://schemas.openxmlformats.org/drawingml/2006/main">
+            <a:srgbClr val="07111F"/>
+          </a:solidFill>
+          <a:ln xmlns:a="http://schemas.openxmlformats.org/drawingml/2006/main" w="0">
+            <a:noFill/>
+            <a:prstDash val="solid"/>
+          </a:ln>
+        </p:spPr>
+      </p:sp>
+      <p:pic>
+        <p:nvPicPr>
+          <p:cNvPr id="26" name=""/>
+          <p:cNvPicPr>
+            <a:picLocks xmlns:a="http://schemas.openxmlformats.org/drawingml/2006/main" noChangeAspect="1"/>
+          </p:cNvPicPr>
+          <p:nvPr/>
+        </p:nvPicPr>
+        <p:blipFill>
+          <a:blip xmlns:r="http://schemas.openxmlformats.org/officeDocument/2006/relationships" xmlns:a="http://schemas.openxmlformats.org/drawingml/2006/main" r:embed="Re3ae7e35873d45fb"/>
+          <a:srcRect xmlns:a="http://schemas.openxmlformats.org/drawingml/2006/main" l="0" t="538" r="0" b="538"/>
+          <a:stretch xmlns:a="http://schemas.openxmlformats.org/drawingml/2006/main">
+            <a:fillRect l="0" t="0" r="0" b="0"/>
+          </a:stretch>
+        </p:blipFill>
+        <p:spPr>
+          <a:xfrm xmlns:a="http://schemas.openxmlformats.org/drawingml/2006/main">
+            <a:off x="476250" y="1657350"/>
+            <a:ext cx="7086600" cy="4381500"/>
+          </a:xfrm>
+          <a:prstGeom xmlns:a="http://schemas.openxmlformats.org/drawingml/2006/main" prst="rect">
+            <a:avLst/>
+          </a:prstGeom>
+        </p:spPr>
+      </p:pic>
+      <p:sp>
+        <p:nvSpPr>
+          <p:cNvPr id="6" name="evidence-card-0">
+            <a:extLst xmlns:a="http://schemas.openxmlformats.org/drawingml/2006/main">
+              <a:ext uri="{FF2B5EF4-FFF2-40B4-BE49-F238E27FC236}">
+                <a16:creationId xmlns:a16="http://schemas.microsoft.com/office/drawing/2014/main" id="{A208BD8A-5674-4462-A7D4-725EEB725C10}"/>
+              </a:ext>
+            </a:extLst>
+          </p:cNvPr>
+          <p:cNvSpPr>
+            <a:spLocks xmlns:a="http://schemas.openxmlformats.org/drawingml/2006/main" noGrp="1"/>
+          </p:cNvSpPr>
+          <p:nvPr/>
+        </p:nvSpPr>
+        <p:spPr>
+          <a:xfrm xmlns:a="http://schemas.openxmlformats.org/drawingml/2006/main">
+            <a:off x="7943850" y="1619250"/>
+            <a:ext cx="3848100" cy="1238250"/>
           </a:xfrm>
           <a:prstGeom xmlns:a="http://schemas.openxmlformats.org/drawingml/2006/main" prst="rect">
             <a:avLst/>
@@ -5185,22 +5190,22 @@
       </p:sp>
       <p:sp>
         <p:nvSpPr>
-          <p:cNvPr id="6" name="metric-accent-4">
-            <a:extLst xmlns:a="http://schemas.openxmlformats.org/drawingml/2006/main">
-              <a:ext uri="{FF2B5EF4-FFF2-40B4-BE49-F238E27FC236}">
-                <a16:creationId xmlns:a16="http://schemas.microsoft.com/office/drawing/2014/main" id="{8E33538D-7D81-41D6-A996-B41435D17A0B}"/>
-              </a:ext>
-            </a:extLst>
-          </p:cNvPr>
-          <p:cNvSpPr>
-            <a:spLocks xmlns:a="http://schemas.openxmlformats.org/drawingml/2006/main" noGrp="1"/>
-          </p:cNvSpPr>
-          <p:nvPr/>
-        </p:nvSpPr>
-        <p:spPr>
-          <a:xfrm xmlns:a="http://schemas.openxmlformats.org/drawingml/2006/main">
-            <a:off x="400050" y="2800350"/>
-            <a:ext cx="3333750" cy="76200"/>
+          <p:cNvPr id="7" name="evidence-card-accent-0">
+            <a:extLst xmlns:a="http://schemas.openxmlformats.org/drawingml/2006/main">
+              <a:ext uri="{FF2B5EF4-FFF2-40B4-BE49-F238E27FC236}">
+                <a16:creationId xmlns:a16="http://schemas.microsoft.com/office/drawing/2014/main" id="{F1EF999B-3F38-439A-98A4-E05114D7C0F9}"/>
+              </a:ext>
+            </a:extLst>
+          </p:cNvPr>
+          <p:cNvSpPr>
+            <a:spLocks xmlns:a="http://schemas.openxmlformats.org/drawingml/2006/main" noGrp="1"/>
+          </p:cNvSpPr>
+          <p:nvPr/>
+        </p:nvSpPr>
+        <p:spPr>
+          <a:xfrm xmlns:a="http://schemas.openxmlformats.org/drawingml/2006/main">
+            <a:off x="7943850" y="1619250"/>
+            <a:ext cx="66675" cy="1238250"/>
           </a:xfrm>
           <a:prstGeom xmlns:a="http://schemas.openxmlformats.org/drawingml/2006/main" prst="rect">
             <a:avLst/>
@@ -5216,22 +5221,22 @@
       </p:sp>
       <p:sp>
         <p:nvSpPr>
-          <p:cNvPr id="7" name="metric-stat-4">
-            <a:extLst xmlns:a="http://schemas.openxmlformats.org/drawingml/2006/main">
-              <a:ext uri="{FF2B5EF4-FFF2-40B4-BE49-F238E27FC236}">
-                <a16:creationId xmlns:a16="http://schemas.microsoft.com/office/drawing/2014/main" id="{4AC4A909-3BB4-4600-B0CA-8A464D1CFE86}"/>
-              </a:ext>
-            </a:extLst>
-          </p:cNvPr>
-          <p:cNvSpPr>
-            <a:spLocks xmlns:a="http://schemas.openxmlformats.org/drawingml/2006/main" noGrp="1"/>
-          </p:cNvSpPr>
-          <p:nvPr/>
-        </p:nvSpPr>
-        <p:spPr>
-          <a:xfrm xmlns:a="http://schemas.openxmlformats.org/drawingml/2006/main">
-            <a:off x="666750" y="3238500"/>
-            <a:ext cx="2800350" cy="857250"/>
+          <p:cNvPr id="8" name="evidence-stat-0">
+            <a:extLst xmlns:a="http://schemas.openxmlformats.org/drawingml/2006/main">
+              <a:ext uri="{FF2B5EF4-FFF2-40B4-BE49-F238E27FC236}">
+                <a16:creationId xmlns:a16="http://schemas.microsoft.com/office/drawing/2014/main" id="{F66D90EE-2F84-47B7-AA6F-0A6744955D34}"/>
+              </a:ext>
+            </a:extLst>
+          </p:cNvPr>
+          <p:cNvSpPr>
+            <a:spLocks xmlns:a="http://schemas.openxmlformats.org/drawingml/2006/main" noGrp="1"/>
+          </p:cNvSpPr>
+          <p:nvPr/>
+        </p:nvSpPr>
+        <p:spPr>
+          <a:xfrm xmlns:a="http://schemas.openxmlformats.org/drawingml/2006/main">
+            <a:off x="8191500" y="1781175"/>
+            <a:ext cx="1295400" cy="447675"/>
           </a:xfrm>
           <a:prstGeom xmlns:a="http://schemas.openxmlformats.org/drawingml/2006/main" prst="rect">
             <a:avLst/>
@@ -5247,7 +5252,7 @@
           <a:lstStyle xmlns:a="http://schemas.openxmlformats.org/drawingml/2006/main"/>
           <a:p xmlns:a="http://schemas.openxmlformats.org/drawingml/2006/main">
             <a:pPr>
-              <a:defRPr sz="4050" b="1">
+              <a:defRPr sz="2400" b="1">
                 <a:solidFill>
                   <a:srgbClr val="07111F"/>
                 </a:solidFill>
@@ -5257,7 +5262,7 @@
               </a:defRPr>
             </a:pPr>
             <a:r>
-              <a:rPr sz="4050" b="1">
+              <a:rPr sz="2400" b="1">
                 <a:solidFill>
                   <a:srgbClr val="07111F"/>
                 </a:solidFill>
@@ -5265,29 +5270,29 @@
                 <a:ea typeface="Helvetica Neue"/>
                 <a:cs typeface="Helvetica Neue"/>
               </a:rPr>
-              <a:t>181</a:t>
-            </a:r>
-          </a:p>
-        </p:txBody>
-      </p:sp>
-      <p:sp>
-        <p:nvSpPr>
-          <p:cNvPr id="8" name="metric-label-4">
-            <a:extLst xmlns:a="http://schemas.openxmlformats.org/drawingml/2006/main">
-              <a:ext uri="{FF2B5EF4-FFF2-40B4-BE49-F238E27FC236}">
-                <a16:creationId xmlns:a16="http://schemas.microsoft.com/office/drawing/2014/main" id="{1FC5DCD3-6B0C-4226-9968-926A7C5DFE55}"/>
-              </a:ext>
-            </a:extLst>
-          </p:cNvPr>
-          <p:cNvSpPr>
-            <a:spLocks xmlns:a="http://schemas.openxmlformats.org/drawingml/2006/main" noGrp="1"/>
-          </p:cNvSpPr>
-          <p:nvPr/>
-        </p:nvSpPr>
-        <p:spPr>
-          <a:xfrm xmlns:a="http://schemas.openxmlformats.org/drawingml/2006/main">
-            <a:off x="666750" y="4267200"/>
-            <a:ext cx="2800350" cy="381000"/>
+              <a:t>191</a:t>
+            </a:r>
+          </a:p>
+        </p:txBody>
+      </p:sp>
+      <p:sp>
+        <p:nvSpPr>
+          <p:cNvPr id="9" name="evidence-label-0">
+            <a:extLst xmlns:a="http://schemas.openxmlformats.org/drawingml/2006/main">
+              <a:ext uri="{FF2B5EF4-FFF2-40B4-BE49-F238E27FC236}">
+                <a16:creationId xmlns:a16="http://schemas.microsoft.com/office/drawing/2014/main" id="{6E817882-96AB-4170-86E3-0EF5FF72F344}"/>
+              </a:ext>
+            </a:extLst>
+          </p:cNvPr>
+          <p:cNvSpPr>
+            <a:spLocks xmlns:a="http://schemas.openxmlformats.org/drawingml/2006/main" noGrp="1"/>
+          </p:cNvSpPr>
+          <p:nvPr/>
+        </p:nvSpPr>
+        <p:spPr>
+          <a:xfrm xmlns:a="http://schemas.openxmlformats.org/drawingml/2006/main">
+            <a:off x="9477375" y="1819275"/>
+            <a:ext cx="2076450" cy="295275"/>
           </a:xfrm>
           <a:prstGeom xmlns:a="http://schemas.openxmlformats.org/drawingml/2006/main" prst="rect">
             <a:avLst/>
@@ -5303,7 +5308,7 @@
           <a:lstStyle xmlns:a="http://schemas.openxmlformats.org/drawingml/2006/main"/>
           <a:p xmlns:a="http://schemas.openxmlformats.org/drawingml/2006/main">
             <a:pPr>
-              <a:defRPr sz="1800" b="1">
+              <a:defRPr sz="1125" b="1">
                 <a:solidFill>
                   <a:srgbClr val="07111F"/>
                 </a:solidFill>
@@ -5313,7 +5318,7 @@
               </a:defRPr>
             </a:pPr>
             <a:r>
-              <a:rPr sz="1800" b="1">
+              <a:rPr sz="1125" b="1">
                 <a:solidFill>
                   <a:srgbClr val="07111F"/>
                 </a:solidFill>
@@ -5321,29 +5326,29 @@
                 <a:ea typeface="Helvetica Neue"/>
                 <a:cs typeface="Helvetica Neue"/>
               </a:rPr>
-              <a:t>Automated tests</a:t>
-            </a:r>
-          </a:p>
-        </p:txBody>
-      </p:sp>
-      <p:sp>
-        <p:nvSpPr>
-          <p:cNvPr id="9" name="metric-detail-4">
-            <a:extLst xmlns:a="http://schemas.openxmlformats.org/drawingml/2006/main">
-              <a:ext uri="{FF2B5EF4-FFF2-40B4-BE49-F238E27FC236}">
-                <a16:creationId xmlns:a16="http://schemas.microsoft.com/office/drawing/2014/main" id="{F72385AC-BFB3-46EC-B2B4-360B7A05247E}"/>
-              </a:ext>
-            </a:extLst>
-          </p:cNvPr>
-          <p:cNvSpPr>
-            <a:spLocks xmlns:a="http://schemas.openxmlformats.org/drawingml/2006/main" noGrp="1"/>
-          </p:cNvSpPr>
-          <p:nvPr/>
-        </p:nvSpPr>
-        <p:spPr>
-          <a:xfrm xmlns:a="http://schemas.openxmlformats.org/drawingml/2006/main">
-            <a:off x="666750" y="4819650"/>
-            <a:ext cx="2800350" cy="609600"/>
+              <a:t>AUTOMATED TESTS</a:t>
+            </a:r>
+          </a:p>
+        </p:txBody>
+      </p:sp>
+      <p:sp>
+        <p:nvSpPr>
+          <p:cNvPr id="10" name="evidence-detail-0">
+            <a:extLst xmlns:a="http://schemas.openxmlformats.org/drawingml/2006/main">
+              <a:ext uri="{FF2B5EF4-FFF2-40B4-BE49-F238E27FC236}">
+                <a16:creationId xmlns:a16="http://schemas.microsoft.com/office/drawing/2014/main" id="{5E773C87-EB51-493A-B286-A80CF6BA09D9}"/>
+              </a:ext>
+            </a:extLst>
+          </p:cNvPr>
+          <p:cNvSpPr>
+            <a:spLocks xmlns:a="http://schemas.openxmlformats.org/drawingml/2006/main" noGrp="1"/>
+          </p:cNvSpPr>
+          <p:nvPr/>
+        </p:nvSpPr>
+        <p:spPr>
+          <a:xfrm xmlns:a="http://schemas.openxmlformats.org/drawingml/2006/main">
+            <a:off x="8191500" y="2352675"/>
+            <a:ext cx="3295650" cy="361950"/>
           </a:xfrm>
           <a:prstGeom xmlns:a="http://schemas.openxmlformats.org/drawingml/2006/main" prst="rect">
             <a:avLst/>
@@ -5359,7 +5364,7 @@
           <a:lstStyle xmlns:a="http://schemas.openxmlformats.org/drawingml/2006/main"/>
           <a:p xmlns:a="http://schemas.openxmlformats.org/drawingml/2006/main">
             <a:pPr>
-              <a:defRPr sz="1275">
+              <a:defRPr sz="1125">
                 <a:solidFill>
                   <a:srgbClr val="526071"/>
                 </a:solidFill>
@@ -5369,7 +5374,7 @@
               </a:defRPr>
             </a:pPr>
             <a:r>
-              <a:rPr sz="1275">
+              <a:rPr sz="1125">
                 <a:solidFill>
                   <a:srgbClr val="526071"/>
                 </a:solidFill>
@@ -5377,29 +5382,259 @@
                 <a:ea typeface="Helvetica Neue"/>
                 <a:cs typeface="Helvetica Neue"/>
               </a:rPr>
-              <a:t>The integrated release covers public mode and read-only smoke.</a:t>
-            </a:r>
-          </a:p>
-        </p:txBody>
-      </p:sp>
-      <p:sp>
-        <p:nvSpPr>
-          <p:cNvPr id="10" name="metric-panel-5">
-            <a:extLst xmlns:a="http://schemas.openxmlformats.org/drawingml/2006/main">
-              <a:ext uri="{FF2B5EF4-FFF2-40B4-BE49-F238E27FC236}">
-                <a16:creationId xmlns:a16="http://schemas.microsoft.com/office/drawing/2014/main" id="{CFE0AA35-0A09-434A-83E6-5D5E7F2FAF30}"/>
-              </a:ext>
-            </a:extLst>
-          </p:cNvPr>
-          <p:cNvSpPr>
-            <a:spLocks xmlns:a="http://schemas.openxmlformats.org/drawingml/2006/main" noGrp="1"/>
-          </p:cNvSpPr>
-          <p:nvPr/>
-        </p:nvSpPr>
-        <p:spPr>
-          <a:xfrm xmlns:a="http://schemas.openxmlformats.org/drawingml/2006/main">
-            <a:off x="4429125" y="2800350"/>
-            <a:ext cx="3333750" cy="2857500"/>
+              <a:t>Integrated release and isolation checks.</a:t>
+            </a:r>
+          </a:p>
+        </p:txBody>
+      </p:sp>
+      <p:sp>
+        <p:nvSpPr>
+          <p:cNvPr id="11" name="evidence-card-1">
+            <a:extLst xmlns:a="http://schemas.openxmlformats.org/drawingml/2006/main">
+              <a:ext uri="{FF2B5EF4-FFF2-40B4-BE49-F238E27FC236}">
+                <a16:creationId xmlns:a16="http://schemas.microsoft.com/office/drawing/2014/main" id="{C7020EB9-1D1E-47C9-8E15-452F205F53A1}"/>
+              </a:ext>
+            </a:extLst>
+          </p:cNvPr>
+          <p:cNvSpPr>
+            <a:spLocks xmlns:a="http://schemas.openxmlformats.org/drawingml/2006/main" noGrp="1"/>
+          </p:cNvSpPr>
+          <p:nvPr/>
+        </p:nvSpPr>
+        <p:spPr>
+          <a:xfrm xmlns:a="http://schemas.openxmlformats.org/drawingml/2006/main">
+            <a:off x="7943850" y="3028950"/>
+            <a:ext cx="3848100" cy="1238250"/>
+          </a:xfrm>
+          <a:prstGeom xmlns:a="http://schemas.openxmlformats.org/drawingml/2006/main" prst="rect">
+            <a:avLst/>
+          </a:prstGeom>
+          <a:solidFill xmlns:a="http://schemas.openxmlformats.org/drawingml/2006/main">
+            <a:srgbClr val="FFF4DD"/>
+          </a:solidFill>
+          <a:ln xmlns:a="http://schemas.openxmlformats.org/drawingml/2006/main" w="0">
+            <a:noFill/>
+            <a:prstDash val="solid"/>
+          </a:ln>
+        </p:spPr>
+      </p:sp>
+      <p:sp>
+        <p:nvSpPr>
+          <p:cNvPr id="12" name="evidence-card-accent-1">
+            <a:extLst xmlns:a="http://schemas.openxmlformats.org/drawingml/2006/main">
+              <a:ext uri="{FF2B5EF4-FFF2-40B4-BE49-F238E27FC236}">
+                <a16:creationId xmlns:a16="http://schemas.microsoft.com/office/drawing/2014/main" id="{5962F90C-C741-4400-9724-2112CBB8AA49}"/>
+              </a:ext>
+            </a:extLst>
+          </p:cNvPr>
+          <p:cNvSpPr>
+            <a:spLocks xmlns:a="http://schemas.openxmlformats.org/drawingml/2006/main" noGrp="1"/>
+          </p:cNvSpPr>
+          <p:nvPr/>
+        </p:nvSpPr>
+        <p:spPr>
+          <a:xfrm xmlns:a="http://schemas.openxmlformats.org/drawingml/2006/main">
+            <a:off x="7943850" y="3028950"/>
+            <a:ext cx="66675" cy="1238250"/>
+          </a:xfrm>
+          <a:prstGeom xmlns:a="http://schemas.openxmlformats.org/drawingml/2006/main" prst="rect">
+            <a:avLst/>
+          </a:prstGeom>
+          <a:solidFill xmlns:a="http://schemas.openxmlformats.org/drawingml/2006/main">
+            <a:srgbClr val="F3A71A"/>
+          </a:solidFill>
+          <a:ln xmlns:a="http://schemas.openxmlformats.org/drawingml/2006/main" w="0">
+            <a:noFill/>
+            <a:prstDash val="solid"/>
+          </a:ln>
+        </p:spPr>
+      </p:sp>
+      <p:sp>
+        <p:nvSpPr>
+          <p:cNvPr id="13" name="evidence-stat-1">
+            <a:extLst xmlns:a="http://schemas.openxmlformats.org/drawingml/2006/main">
+              <a:ext uri="{FF2B5EF4-FFF2-40B4-BE49-F238E27FC236}">
+                <a16:creationId xmlns:a16="http://schemas.microsoft.com/office/drawing/2014/main" id="{A7E1F876-4B7D-41C7-9C3F-F0858F20287D}"/>
+              </a:ext>
+            </a:extLst>
+          </p:cNvPr>
+          <p:cNvSpPr>
+            <a:spLocks xmlns:a="http://schemas.openxmlformats.org/drawingml/2006/main" noGrp="1"/>
+          </p:cNvSpPr>
+          <p:nvPr/>
+        </p:nvSpPr>
+        <p:spPr>
+          <a:xfrm xmlns:a="http://schemas.openxmlformats.org/drawingml/2006/main">
+            <a:off x="8191500" y="3190875"/>
+            <a:ext cx="1295400" cy="447675"/>
+          </a:xfrm>
+          <a:prstGeom xmlns:a="http://schemas.openxmlformats.org/drawingml/2006/main" prst="rect">
+            <a:avLst/>
+          </a:prstGeom>
+          <a:noFill xmlns:a="http://schemas.openxmlformats.org/drawingml/2006/main"/>
+          <a:ln xmlns:a="http://schemas.openxmlformats.org/drawingml/2006/main" w="0">
+            <a:noFill/>
+            <a:prstDash val="solid"/>
+          </a:ln>
+        </p:spPr>
+        <p:txBody>
+          <a:bodyPr xmlns:a="http://schemas.openxmlformats.org/drawingml/2006/main"/>
+          <a:lstStyle xmlns:a="http://schemas.openxmlformats.org/drawingml/2006/main"/>
+          <a:p xmlns:a="http://schemas.openxmlformats.org/drawingml/2006/main">
+            <a:pPr>
+              <a:defRPr sz="2025" b="1">
+                <a:solidFill>
+                  <a:srgbClr val="07111F"/>
+                </a:solidFill>
+                <a:latin typeface="Helvetica Neue"/>
+                <a:ea typeface="Helvetica Neue"/>
+                <a:cs typeface="Helvetica Neue"/>
+              </a:defRPr>
+            </a:pPr>
+            <a:r>
+              <a:rPr sz="2025" b="1">
+                <a:solidFill>
+                  <a:srgbClr val="07111F"/>
+                </a:solidFill>
+                <a:latin typeface="Helvetica Neue"/>
+                <a:ea typeface="Helvetica Neue"/>
+                <a:cs typeface="Helvetica Neue"/>
+              </a:rPr>
+              <a:t>$100K</a:t>
+            </a:r>
+          </a:p>
+        </p:txBody>
+      </p:sp>
+      <p:sp>
+        <p:nvSpPr>
+          <p:cNvPr id="14" name="evidence-label-1">
+            <a:extLst xmlns:a="http://schemas.openxmlformats.org/drawingml/2006/main">
+              <a:ext uri="{FF2B5EF4-FFF2-40B4-BE49-F238E27FC236}">
+                <a16:creationId xmlns:a16="http://schemas.microsoft.com/office/drawing/2014/main" id="{50FAFAA0-3AEB-4284-B9A0-10F462A5E352}"/>
+              </a:ext>
+            </a:extLst>
+          </p:cNvPr>
+          <p:cNvSpPr>
+            <a:spLocks xmlns:a="http://schemas.openxmlformats.org/drawingml/2006/main" noGrp="1"/>
+          </p:cNvSpPr>
+          <p:nvPr/>
+        </p:nvSpPr>
+        <p:spPr>
+          <a:xfrm xmlns:a="http://schemas.openxmlformats.org/drawingml/2006/main">
+            <a:off x="9477375" y="3228975"/>
+            <a:ext cx="2076450" cy="295275"/>
+          </a:xfrm>
+          <a:prstGeom xmlns:a="http://schemas.openxmlformats.org/drawingml/2006/main" prst="rect">
+            <a:avLst/>
+          </a:prstGeom>
+          <a:noFill xmlns:a="http://schemas.openxmlformats.org/drawingml/2006/main"/>
+          <a:ln xmlns:a="http://schemas.openxmlformats.org/drawingml/2006/main" w="0">
+            <a:noFill/>
+            <a:prstDash val="solid"/>
+          </a:ln>
+        </p:spPr>
+        <p:txBody>
+          <a:bodyPr xmlns:a="http://schemas.openxmlformats.org/drawingml/2006/main"/>
+          <a:lstStyle xmlns:a="http://schemas.openxmlformats.org/drawingml/2006/main"/>
+          <a:p xmlns:a="http://schemas.openxmlformats.org/drawingml/2006/main">
+            <a:pPr>
+              <a:defRPr sz="1125" b="1">
+                <a:solidFill>
+                  <a:srgbClr val="07111F"/>
+                </a:solidFill>
+                <a:latin typeface="Helvetica Neue"/>
+                <a:ea typeface="Helvetica Neue"/>
+                <a:cs typeface="Helvetica Neue"/>
+              </a:defRPr>
+            </a:pPr>
+            <a:r>
+              <a:rPr sz="1125" b="1">
+                <a:solidFill>
+                  <a:srgbClr val="07111F"/>
+                </a:solidFill>
+                <a:latin typeface="Helvetica Neue"/>
+                <a:ea typeface="Helvetica Neue"/>
+                <a:cs typeface="Helvetica Neue"/>
+              </a:rPr>
+              <a:t>PAPER BASELINE</a:t>
+            </a:r>
+          </a:p>
+        </p:txBody>
+      </p:sp>
+      <p:sp>
+        <p:nvSpPr>
+          <p:cNvPr id="15" name="evidence-detail-1">
+            <a:extLst xmlns:a="http://schemas.openxmlformats.org/drawingml/2006/main">
+              <a:ext uri="{FF2B5EF4-FFF2-40B4-BE49-F238E27FC236}">
+                <a16:creationId xmlns:a16="http://schemas.microsoft.com/office/drawing/2014/main" id="{36BFE04B-CE87-495F-A5E4-4DA4DAFD67D3}"/>
+              </a:ext>
+            </a:extLst>
+          </p:cNvPr>
+          <p:cNvSpPr>
+            <a:spLocks xmlns:a="http://schemas.openxmlformats.org/drawingml/2006/main" noGrp="1"/>
+          </p:cNvSpPr>
+          <p:nvPr/>
+        </p:nvSpPr>
+        <p:spPr>
+          <a:xfrm xmlns:a="http://schemas.openxmlformats.org/drawingml/2006/main">
+            <a:off x="8191500" y="3762375"/>
+            <a:ext cx="3295650" cy="361950"/>
+          </a:xfrm>
+          <a:prstGeom xmlns:a="http://schemas.openxmlformats.org/drawingml/2006/main" prst="rect">
+            <a:avLst/>
+          </a:prstGeom>
+          <a:noFill xmlns:a="http://schemas.openxmlformats.org/drawingml/2006/main"/>
+          <a:ln xmlns:a="http://schemas.openxmlformats.org/drawingml/2006/main" w="0">
+            <a:noFill/>
+            <a:prstDash val="solid"/>
+          </a:ln>
+        </p:spPr>
+        <p:txBody>
+          <a:bodyPr xmlns:a="http://schemas.openxmlformats.org/drawingml/2006/main"/>
+          <a:lstStyle xmlns:a="http://schemas.openxmlformats.org/drawingml/2006/main"/>
+          <a:p xmlns:a="http://schemas.openxmlformats.org/drawingml/2006/main">
+            <a:pPr>
+              <a:defRPr sz="1125">
+                <a:solidFill>
+                  <a:srgbClr val="526071"/>
+                </a:solidFill>
+                <a:latin typeface="Helvetica Neue"/>
+                <a:ea typeface="Helvetica Neue"/>
+                <a:cs typeface="Helvetica Neue"/>
+              </a:defRPr>
+            </a:pPr>
+            <a:r>
+              <a:rPr sz="1125">
+                <a:solidFill>
+                  <a:srgbClr val="526071"/>
+                </a:solidFill>
+                <a:latin typeface="Helvetica Neue"/>
+                <a:ea typeface="Helvetica Neue"/>
+                <a:cs typeface="Helvetica Neue"/>
+              </a:rPr>
+              <a:t>Flat account; zero orders on Aug 31.</a:t>
+            </a:r>
+          </a:p>
+        </p:txBody>
+      </p:sp>
+      <p:sp>
+        <p:nvSpPr>
+          <p:cNvPr id="16" name="evidence-card-2">
+            <a:extLst xmlns:a="http://schemas.openxmlformats.org/drawingml/2006/main">
+              <a:ext uri="{FF2B5EF4-FFF2-40B4-BE49-F238E27FC236}">
+                <a16:creationId xmlns:a16="http://schemas.microsoft.com/office/drawing/2014/main" id="{155A55DA-8348-4E30-93F9-80B20AA74359}"/>
+              </a:ext>
+            </a:extLst>
+          </p:cNvPr>
+          <p:cNvSpPr>
+            <a:spLocks xmlns:a="http://schemas.openxmlformats.org/drawingml/2006/main" noGrp="1"/>
+          </p:cNvSpPr>
+          <p:nvPr/>
+        </p:nvSpPr>
+        <p:spPr>
+          <a:xfrm xmlns:a="http://schemas.openxmlformats.org/drawingml/2006/main">
+            <a:off x="7943850" y="4438650"/>
+            <a:ext cx="3848100" cy="1238250"/>
           </a:xfrm>
           <a:prstGeom xmlns:a="http://schemas.openxmlformats.org/drawingml/2006/main" prst="rect">
             <a:avLst/>
@@ -5415,252 +5650,22 @@
       </p:sp>
       <p:sp>
         <p:nvSpPr>
-          <p:cNvPr id="11" name="metric-accent-5">
-            <a:extLst xmlns:a="http://schemas.openxmlformats.org/drawingml/2006/main">
-              <a:ext uri="{FF2B5EF4-FFF2-40B4-BE49-F238E27FC236}">
-                <a16:creationId xmlns:a16="http://schemas.microsoft.com/office/drawing/2014/main" id="{E39A3C64-1806-43AE-ACBE-145882CC0363}"/>
-              </a:ext>
-            </a:extLst>
-          </p:cNvPr>
-          <p:cNvSpPr>
-            <a:spLocks xmlns:a="http://schemas.openxmlformats.org/drawingml/2006/main" noGrp="1"/>
-          </p:cNvSpPr>
-          <p:nvPr/>
-        </p:nvSpPr>
-        <p:spPr>
-          <a:xfrm xmlns:a="http://schemas.openxmlformats.org/drawingml/2006/main">
-            <a:off x="4429125" y="2800350"/>
-            <a:ext cx="3333750" cy="76200"/>
-          </a:xfrm>
-          <a:prstGeom xmlns:a="http://schemas.openxmlformats.org/drawingml/2006/main" prst="rect">
-            <a:avLst/>
-          </a:prstGeom>
-          <a:solidFill xmlns:a="http://schemas.openxmlformats.org/drawingml/2006/main">
-            <a:srgbClr val="F3A71A"/>
-          </a:solidFill>
-          <a:ln xmlns:a="http://schemas.openxmlformats.org/drawingml/2006/main" w="0">
-            <a:noFill/>
-            <a:prstDash val="solid"/>
-          </a:ln>
-        </p:spPr>
-      </p:sp>
-      <p:sp>
-        <p:nvSpPr>
-          <p:cNvPr id="12" name="metric-stat-5">
-            <a:extLst xmlns:a="http://schemas.openxmlformats.org/drawingml/2006/main">
-              <a:ext uri="{FF2B5EF4-FFF2-40B4-BE49-F238E27FC236}">
-                <a16:creationId xmlns:a16="http://schemas.microsoft.com/office/drawing/2014/main" id="{3A3034ED-90D8-4D07-983D-674580271768}"/>
-              </a:ext>
-            </a:extLst>
-          </p:cNvPr>
-          <p:cNvSpPr>
-            <a:spLocks xmlns:a="http://schemas.openxmlformats.org/drawingml/2006/main" noGrp="1"/>
-          </p:cNvSpPr>
-          <p:nvPr/>
-        </p:nvSpPr>
-        <p:spPr>
-          <a:xfrm xmlns:a="http://schemas.openxmlformats.org/drawingml/2006/main">
-            <a:off x="4695825" y="3238500"/>
-            <a:ext cx="2800350" cy="857250"/>
-          </a:xfrm>
-          <a:prstGeom xmlns:a="http://schemas.openxmlformats.org/drawingml/2006/main" prst="rect">
-            <a:avLst/>
-          </a:prstGeom>
-          <a:noFill xmlns:a="http://schemas.openxmlformats.org/drawingml/2006/main"/>
-          <a:ln xmlns:a="http://schemas.openxmlformats.org/drawingml/2006/main" w="0">
-            <a:noFill/>
-            <a:prstDash val="solid"/>
-          </a:ln>
-        </p:spPr>
-        <p:txBody>
-          <a:bodyPr xmlns:a="http://schemas.openxmlformats.org/drawingml/2006/main"/>
-          <a:lstStyle xmlns:a="http://schemas.openxmlformats.org/drawingml/2006/main"/>
-          <a:p xmlns:a="http://schemas.openxmlformats.org/drawingml/2006/main">
-            <a:pPr>
-              <a:defRPr sz="4050" b="1">
-                <a:solidFill>
-                  <a:srgbClr val="07111F"/>
-                </a:solidFill>
-                <a:latin typeface="Helvetica Neue"/>
-                <a:ea typeface="Helvetica Neue"/>
-                <a:cs typeface="Helvetica Neue"/>
-              </a:defRPr>
-            </a:pPr>
-            <a:r>
-              <a:rPr sz="4050" b="1">
-                <a:solidFill>
-                  <a:srgbClr val="07111F"/>
-                </a:solidFill>
-                <a:latin typeface="Helvetica Neue"/>
-                <a:ea typeface="Helvetica Neue"/>
-                <a:cs typeface="Helvetica Neue"/>
-              </a:rPr>
-              <a:t>7</a:t>
-            </a:r>
-          </a:p>
-        </p:txBody>
-      </p:sp>
-      <p:sp>
-        <p:nvSpPr>
-          <p:cNvPr id="13" name="metric-label-5">
-            <a:extLst xmlns:a="http://schemas.openxmlformats.org/drawingml/2006/main">
-              <a:ext uri="{FF2B5EF4-FFF2-40B4-BE49-F238E27FC236}">
-                <a16:creationId xmlns:a16="http://schemas.microsoft.com/office/drawing/2014/main" id="{820A8370-E134-4841-A63D-FD401A2400C9}"/>
-              </a:ext>
-            </a:extLst>
-          </p:cNvPr>
-          <p:cNvSpPr>
-            <a:spLocks xmlns:a="http://schemas.openxmlformats.org/drawingml/2006/main" noGrp="1"/>
-          </p:cNvSpPr>
-          <p:nvPr/>
-        </p:nvSpPr>
-        <p:spPr>
-          <a:xfrm xmlns:a="http://schemas.openxmlformats.org/drawingml/2006/main">
-            <a:off x="4695825" y="4267200"/>
-            <a:ext cx="2800350" cy="381000"/>
-          </a:xfrm>
-          <a:prstGeom xmlns:a="http://schemas.openxmlformats.org/drawingml/2006/main" prst="rect">
-            <a:avLst/>
-          </a:prstGeom>
-          <a:noFill xmlns:a="http://schemas.openxmlformats.org/drawingml/2006/main"/>
-          <a:ln xmlns:a="http://schemas.openxmlformats.org/drawingml/2006/main" w="0">
-            <a:noFill/>
-            <a:prstDash val="solid"/>
-          </a:ln>
-        </p:spPr>
-        <p:txBody>
-          <a:bodyPr xmlns:a="http://schemas.openxmlformats.org/drawingml/2006/main"/>
-          <a:lstStyle xmlns:a="http://schemas.openxmlformats.org/drawingml/2006/main"/>
-          <a:p xmlns:a="http://schemas.openxmlformats.org/drawingml/2006/main">
-            <a:pPr>
-              <a:defRPr sz="1800" b="1">
-                <a:solidFill>
-                  <a:srgbClr val="07111F"/>
-                </a:solidFill>
-                <a:latin typeface="Helvetica Neue"/>
-                <a:ea typeface="Helvetica Neue"/>
-                <a:cs typeface="Helvetica Neue"/>
-              </a:defRPr>
-            </a:pPr>
-            <a:r>
-              <a:rPr sz="1800" b="1">
-                <a:solidFill>
-                  <a:srgbClr val="07111F"/>
-                </a:solidFill>
-                <a:latin typeface="Helvetica Neue"/>
-                <a:ea typeface="Helvetica Neue"/>
-                <a:cs typeface="Helvetica Neue"/>
-              </a:rPr>
-              <a:t>Eligible events</a:t>
-            </a:r>
-          </a:p>
-        </p:txBody>
-      </p:sp>
-      <p:sp>
-        <p:nvSpPr>
-          <p:cNvPr id="14" name="metric-detail-5">
-            <a:extLst xmlns:a="http://schemas.openxmlformats.org/drawingml/2006/main">
-              <a:ext uri="{FF2B5EF4-FFF2-40B4-BE49-F238E27FC236}">
-                <a16:creationId xmlns:a16="http://schemas.microsoft.com/office/drawing/2014/main" id="{CF92E8E4-A88C-4B5F-B497-7547532AD0CE}"/>
-              </a:ext>
-            </a:extLst>
-          </p:cNvPr>
-          <p:cNvSpPr>
-            <a:spLocks xmlns:a="http://schemas.openxmlformats.org/drawingml/2006/main" noGrp="1"/>
-          </p:cNvSpPr>
-          <p:nvPr/>
-        </p:nvSpPr>
-        <p:spPr>
-          <a:xfrm xmlns:a="http://schemas.openxmlformats.org/drawingml/2006/main">
-            <a:off x="4695825" y="4819650"/>
-            <a:ext cx="2800350" cy="609600"/>
-          </a:xfrm>
-          <a:prstGeom xmlns:a="http://schemas.openxmlformats.org/drawingml/2006/main" prst="rect">
-            <a:avLst/>
-          </a:prstGeom>
-          <a:noFill xmlns:a="http://schemas.openxmlformats.org/drawingml/2006/main"/>
-          <a:ln xmlns:a="http://schemas.openxmlformats.org/drawingml/2006/main" w="0">
-            <a:noFill/>
-            <a:prstDash val="solid"/>
-          </a:ln>
-        </p:spPr>
-        <p:txBody>
-          <a:bodyPr xmlns:a="http://schemas.openxmlformats.org/drawingml/2006/main"/>
-          <a:lstStyle xmlns:a="http://schemas.openxmlformats.org/drawingml/2006/main"/>
-          <a:p xmlns:a="http://schemas.openxmlformats.org/drawingml/2006/main">
-            <a:pPr>
-              <a:defRPr sz="1275">
-                <a:solidFill>
-                  <a:srgbClr val="526071"/>
-                </a:solidFill>
-                <a:latin typeface="Helvetica Neue"/>
-                <a:ea typeface="Helvetica Neue"/>
-                <a:cs typeface="Helvetica Neue"/>
-              </a:defRPr>
-            </a:pPr>
-            <a:r>
-              <a:rPr sz="1275">
-                <a:solidFill>
-                  <a:srgbClr val="526071"/>
-                </a:solidFill>
-                <a:latin typeface="Helvetica Neue"/>
-                <a:ea typeface="Helvetica Neue"/>
-                <a:cs typeface="Helvetica Neue"/>
-              </a:rPr>
-              <a:t>Four Sep 1 and three Sep 2 after-close candidates.</a:t>
-            </a:r>
-          </a:p>
-        </p:txBody>
-      </p:sp>
-      <p:sp>
-        <p:nvSpPr>
-          <p:cNvPr id="15" name="metric-panel-6">
-            <a:extLst xmlns:a="http://schemas.openxmlformats.org/drawingml/2006/main">
-              <a:ext uri="{FF2B5EF4-FFF2-40B4-BE49-F238E27FC236}">
-                <a16:creationId xmlns:a16="http://schemas.microsoft.com/office/drawing/2014/main" id="{4437E13C-D011-4212-9914-B6694B971E59}"/>
-              </a:ext>
-            </a:extLst>
-          </p:cNvPr>
-          <p:cNvSpPr>
-            <a:spLocks xmlns:a="http://schemas.openxmlformats.org/drawingml/2006/main" noGrp="1"/>
-          </p:cNvSpPr>
-          <p:nvPr/>
-        </p:nvSpPr>
-        <p:spPr>
-          <a:xfrm xmlns:a="http://schemas.openxmlformats.org/drawingml/2006/main">
-            <a:off x="8458200" y="2800350"/>
-            <a:ext cx="3333750" cy="2857500"/>
-          </a:xfrm>
-          <a:prstGeom xmlns:a="http://schemas.openxmlformats.org/drawingml/2006/main" prst="rect">
-            <a:avLst/>
-          </a:prstGeom>
-          <a:solidFill xmlns:a="http://schemas.openxmlformats.org/drawingml/2006/main">
-            <a:srgbClr val="EDF3F6"/>
-          </a:solidFill>
-          <a:ln xmlns:a="http://schemas.openxmlformats.org/drawingml/2006/main" w="0">
-            <a:noFill/>
-            <a:prstDash val="solid"/>
-          </a:ln>
-        </p:spPr>
-      </p:sp>
-      <p:sp>
-        <p:nvSpPr>
-          <p:cNvPr id="16" name="metric-accent-6">
-            <a:extLst xmlns:a="http://schemas.openxmlformats.org/drawingml/2006/main">
-              <a:ext uri="{FF2B5EF4-FFF2-40B4-BE49-F238E27FC236}">
-                <a16:creationId xmlns:a16="http://schemas.microsoft.com/office/drawing/2014/main" id="{81211977-97B3-4956-B694-77C4D5EA440D}"/>
-              </a:ext>
-            </a:extLst>
-          </p:cNvPr>
-          <p:cNvSpPr>
-            <a:spLocks xmlns:a="http://schemas.openxmlformats.org/drawingml/2006/main" noGrp="1"/>
-          </p:cNvSpPr>
-          <p:nvPr/>
-        </p:nvSpPr>
-        <p:spPr>
-          <a:xfrm xmlns:a="http://schemas.openxmlformats.org/drawingml/2006/main">
-            <a:off x="8458200" y="2800350"/>
-            <a:ext cx="3333750" cy="76200"/>
+          <p:cNvPr id="17" name="evidence-card-accent-2">
+            <a:extLst xmlns:a="http://schemas.openxmlformats.org/drawingml/2006/main">
+              <a:ext uri="{FF2B5EF4-FFF2-40B4-BE49-F238E27FC236}">
+                <a16:creationId xmlns:a16="http://schemas.microsoft.com/office/drawing/2014/main" id="{A896C6DC-3883-4E42-803F-E44DA535DCA7}"/>
+              </a:ext>
+            </a:extLst>
+          </p:cNvPr>
+          <p:cNvSpPr>
+            <a:spLocks xmlns:a="http://schemas.openxmlformats.org/drawingml/2006/main" noGrp="1"/>
+          </p:cNvSpPr>
+          <p:nvPr/>
+        </p:nvSpPr>
+        <p:spPr>
+          <a:xfrm xmlns:a="http://schemas.openxmlformats.org/drawingml/2006/main">
+            <a:off x="7943850" y="4438650"/>
+            <a:ext cx="66675" cy="1238250"/>
           </a:xfrm>
           <a:prstGeom xmlns:a="http://schemas.openxmlformats.org/drawingml/2006/main" prst="rect">
             <a:avLst/>
@@ -5676,22 +5681,22 @@
       </p:sp>
       <p:sp>
         <p:nvSpPr>
-          <p:cNvPr id="17" name="metric-stat-6">
-            <a:extLst xmlns:a="http://schemas.openxmlformats.org/drawingml/2006/main">
-              <a:ext uri="{FF2B5EF4-FFF2-40B4-BE49-F238E27FC236}">
-                <a16:creationId xmlns:a16="http://schemas.microsoft.com/office/drawing/2014/main" id="{330A69ED-57C0-46DC-9813-41AFD1511E0C}"/>
-              </a:ext>
-            </a:extLst>
-          </p:cNvPr>
-          <p:cNvSpPr>
-            <a:spLocks xmlns:a="http://schemas.openxmlformats.org/drawingml/2006/main" noGrp="1"/>
-          </p:cNvSpPr>
-          <p:nvPr/>
-        </p:nvSpPr>
-        <p:spPr>
-          <a:xfrm xmlns:a="http://schemas.openxmlformats.org/drawingml/2006/main">
-            <a:off x="8724900" y="3238500"/>
-            <a:ext cx="2800350" cy="857250"/>
+          <p:cNvPr id="18" name="evidence-stat-2">
+            <a:extLst xmlns:a="http://schemas.openxmlformats.org/drawingml/2006/main">
+              <a:ext uri="{FF2B5EF4-FFF2-40B4-BE49-F238E27FC236}">
+                <a16:creationId xmlns:a16="http://schemas.microsoft.com/office/drawing/2014/main" id="{C68E02C1-A727-4E35-8637-ED5385886294}"/>
+              </a:ext>
+            </a:extLst>
+          </p:cNvPr>
+          <p:cNvSpPr>
+            <a:spLocks xmlns:a="http://schemas.openxmlformats.org/drawingml/2006/main" noGrp="1"/>
+          </p:cNvSpPr>
+          <p:nvPr/>
+        </p:nvSpPr>
+        <p:spPr>
+          <a:xfrm xmlns:a="http://schemas.openxmlformats.org/drawingml/2006/main">
+            <a:off x="8191500" y="4600575"/>
+            <a:ext cx="1295400" cy="447675"/>
           </a:xfrm>
           <a:prstGeom xmlns:a="http://schemas.openxmlformats.org/drawingml/2006/main" prst="rect">
             <a:avLst/>
@@ -5707,7 +5712,7 @@
           <a:lstStyle xmlns:a="http://schemas.openxmlformats.org/drawingml/2006/main"/>
           <a:p xmlns:a="http://schemas.openxmlformats.org/drawingml/2006/main">
             <a:pPr>
-              <a:defRPr sz="4050" b="1">
+              <a:defRPr sz="2025" b="1">
                 <a:solidFill>
                   <a:srgbClr val="07111F"/>
                 </a:solidFill>
@@ -5717,7 +5722,7 @@
               </a:defRPr>
             </a:pPr>
             <a:r>
-              <a:rPr sz="4050" b="1">
+              <a:rPr sz="2025" b="1">
                 <a:solidFill>
                   <a:srgbClr val="07111F"/>
                 </a:solidFill>
@@ -5725,29 +5730,29 @@
                 <a:ea typeface="Helvetica Neue"/>
                 <a:cs typeface="Helvetica Neue"/>
               </a:rPr>
-              <a:t>2</a:t>
-            </a:r>
-          </a:p>
-        </p:txBody>
-      </p:sp>
-      <p:sp>
-        <p:nvSpPr>
-          <p:cNvPr id="18" name="metric-label-6">
-            <a:extLst xmlns:a="http://schemas.openxmlformats.org/drawingml/2006/main">
-              <a:ext uri="{FF2B5EF4-FFF2-40B4-BE49-F238E27FC236}">
-                <a16:creationId xmlns:a16="http://schemas.microsoft.com/office/drawing/2014/main" id="{F6648B0D-C183-4D03-9DBF-01AED0D2F74C}"/>
-              </a:ext>
-            </a:extLst>
-          </p:cNvPr>
-          <p:cNvSpPr>
-            <a:spLocks xmlns:a="http://schemas.openxmlformats.org/drawingml/2006/main" noGrp="1"/>
-          </p:cNvSpPr>
-          <p:nvPr/>
-        </p:nvSpPr>
-        <p:spPr>
-          <a:xfrm xmlns:a="http://schemas.openxmlformats.org/drawingml/2006/main">
-            <a:off x="8724900" y="4267200"/>
-            <a:ext cx="2800350" cy="381000"/>
+              <a:t>READY</a:t>
+            </a:r>
+          </a:p>
+        </p:txBody>
+      </p:sp>
+      <p:sp>
+        <p:nvSpPr>
+          <p:cNvPr id="19" name="evidence-label-2">
+            <a:extLst xmlns:a="http://schemas.openxmlformats.org/drawingml/2006/main">
+              <a:ext uri="{FF2B5EF4-FFF2-40B4-BE49-F238E27FC236}">
+                <a16:creationId xmlns:a16="http://schemas.microsoft.com/office/drawing/2014/main" id="{2C542FBB-09AB-440B-87FC-FA25893C56EE}"/>
+              </a:ext>
+            </a:extLst>
+          </p:cNvPr>
+          <p:cNvSpPr>
+            <a:spLocks xmlns:a="http://schemas.openxmlformats.org/drawingml/2006/main" noGrp="1"/>
+          </p:cNvSpPr>
+          <p:nvPr/>
+        </p:nvSpPr>
+        <p:spPr>
+          <a:xfrm xmlns:a="http://schemas.openxmlformats.org/drawingml/2006/main">
+            <a:off x="9477375" y="4638675"/>
+            <a:ext cx="2076450" cy="295275"/>
           </a:xfrm>
           <a:prstGeom xmlns:a="http://schemas.openxmlformats.org/drawingml/2006/main" prst="rect">
             <a:avLst/>
@@ -5763,7 +5768,7 @@
           <a:lstStyle xmlns:a="http://schemas.openxmlformats.org/drawingml/2006/main"/>
           <a:p xmlns:a="http://schemas.openxmlformats.org/drawingml/2006/main">
             <a:pPr>
-              <a:defRPr sz="1800" b="1">
+              <a:defRPr sz="1125" b="1">
                 <a:solidFill>
                   <a:srgbClr val="07111F"/>
                 </a:solidFill>
@@ -5773,7 +5778,7 @@
               </a:defRPr>
             </a:pPr>
             <a:r>
-              <a:rPr sz="1800" b="1">
+              <a:rPr sz="1125" b="1">
                 <a:solidFill>
                   <a:srgbClr val="07111F"/>
                 </a:solidFill>
@@ -5781,29 +5786,29 @@
                 <a:ea typeface="Helvetica Neue"/>
                 <a:cs typeface="Helvetica Neue"/>
               </a:rPr>
-              <a:t>Explicit exclusions</a:t>
-            </a:r>
-          </a:p>
-        </p:txBody>
-      </p:sp>
-      <p:sp>
-        <p:nvSpPr>
-          <p:cNvPr id="19" name="metric-detail-6">
-            <a:extLst xmlns:a="http://schemas.openxmlformats.org/drawingml/2006/main">
-              <a:ext uri="{FF2B5EF4-FFF2-40B4-BE49-F238E27FC236}">
-                <a16:creationId xmlns:a16="http://schemas.microsoft.com/office/drawing/2014/main" id="{4FF0C86E-10AF-480D-A6D7-07F14AC773A7}"/>
-              </a:ext>
-            </a:extLst>
-          </p:cNvPr>
-          <p:cNvSpPr>
-            <a:spLocks xmlns:a="http://schemas.openxmlformats.org/drawingml/2006/main" noGrp="1"/>
-          </p:cNvSpPr>
-          <p:nvPr/>
-        </p:nvSpPr>
-        <p:spPr>
-          <a:xfrm xmlns:a="http://schemas.openxmlformats.org/drawingml/2006/main">
-            <a:off x="8724900" y="4819650"/>
-            <a:ext cx="2800350" cy="609600"/>
+              <a:t>MCP + WORKER</a:t>
+            </a:r>
+          </a:p>
+        </p:txBody>
+      </p:sp>
+      <p:sp>
+        <p:nvSpPr>
+          <p:cNvPr id="20" name="evidence-detail-2">
+            <a:extLst xmlns:a="http://schemas.openxmlformats.org/drawingml/2006/main">
+              <a:ext uri="{FF2B5EF4-FFF2-40B4-BE49-F238E27FC236}">
+                <a16:creationId xmlns:a16="http://schemas.microsoft.com/office/drawing/2014/main" id="{F06C17D6-B4CE-46D7-8F9A-EC584F0C1C6D}"/>
+              </a:ext>
+            </a:extLst>
+          </p:cNvPr>
+          <p:cNvSpPr>
+            <a:spLocks xmlns:a="http://schemas.openxmlformats.org/drawingml/2006/main" noGrp="1"/>
+          </p:cNvSpPr>
+          <p:nvPr/>
+        </p:nvSpPr>
+        <p:spPr>
+          <a:xfrm xmlns:a="http://schemas.openxmlformats.org/drawingml/2006/main">
+            <a:off x="8191500" y="5172075"/>
+            <a:ext cx="3295650" cy="361950"/>
           </a:xfrm>
           <a:prstGeom xmlns:a="http://schemas.openxmlformats.org/drawingml/2006/main" prst="rect">
             <a:avLst/>
@@ -5819,7 +5824,7 @@
           <a:lstStyle xmlns:a="http://schemas.openxmlformats.org/drawingml/2006/main"/>
           <a:p xmlns:a="http://schemas.openxmlformats.org/drawingml/2006/main">
             <a:pPr>
-              <a:defRPr sz="1275">
+              <a:defRPr sz="1125">
                 <a:solidFill>
                   <a:srgbClr val="526071"/>
                 </a:solidFill>
@@ -5829,7 +5834,7 @@
               </a:defRPr>
             </a:pPr>
             <a:r>
-              <a:rPr sz="1275">
+              <a:rPr sz="1125">
                 <a:solidFill>
                   <a:srgbClr val="526071"/>
                 </a:solidFill>
@@ -5837,29 +5842,29 @@
                 <a:ea typeface="Helvetica Neue"/>
                 <a:cs typeface="Helvetica Neue"/>
               </a:rPr>
-              <a:t>Ambiguous timing and unavailable weekly expirations fail closed.</a:t>
-            </a:r>
-          </a:p>
-        </p:txBody>
-      </p:sp>
-      <p:sp>
-        <p:nvSpPr>
-          <p:cNvPr id="20" name="evidence-footer">
-            <a:extLst xmlns:a="http://schemas.openxmlformats.org/drawingml/2006/main">
-              <a:ext uri="{FF2B5EF4-FFF2-40B4-BE49-F238E27FC236}">
-                <a16:creationId xmlns:a16="http://schemas.microsoft.com/office/drawing/2014/main" id="{AAFC8D7A-8D21-4B13-8F29-D49D91484C1F}"/>
-              </a:ext>
-            </a:extLst>
-          </p:cNvPr>
-          <p:cNvSpPr>
-            <a:spLocks xmlns:a="http://schemas.openxmlformats.org/drawingml/2006/main" noGrp="1"/>
-          </p:cNvSpPr>
-          <p:nvPr/>
-        </p:nvSpPr>
-        <p:spPr>
-          <a:xfrm xmlns:a="http://schemas.openxmlformats.org/drawingml/2006/main">
-            <a:off x="400050" y="5905500"/>
-            <a:ext cx="10382250" cy="285750"/>
+              <a:t>Read-only smoke passed on the Droplet.</a:t>
+            </a:r>
+          </a:p>
+        </p:txBody>
+      </p:sp>
+      <p:sp>
+        <p:nvSpPr>
+          <p:cNvPr id="21" name="evidence-footer">
+            <a:extLst xmlns:a="http://schemas.openxmlformats.org/drawingml/2006/main">
+              <a:ext uri="{FF2B5EF4-FFF2-40B4-BE49-F238E27FC236}">
+                <a16:creationId xmlns:a16="http://schemas.microsoft.com/office/drawing/2014/main" id="{834B8B03-52AB-4228-A0AE-5497FA83A0C4}"/>
+              </a:ext>
+            </a:extLst>
+          </p:cNvPr>
+          <p:cNvSpPr>
+            <a:spLocks xmlns:a="http://schemas.openxmlformats.org/drawingml/2006/main" noGrp="1"/>
+          </p:cNvSpPr>
+          <p:nvPr/>
+        </p:nvSpPr>
+        <p:spPr>
+          <a:xfrm xmlns:a="http://schemas.openxmlformats.org/drawingml/2006/main">
+            <a:off x="7943850" y="5905500"/>
+            <a:ext cx="3848100" cy="361950"/>
           </a:xfrm>
           <a:prstGeom xmlns:a="http://schemas.openxmlformats.org/drawingml/2006/main" prst="rect">
             <a:avLst/>
@@ -5875,7 +5880,7 @@
           <a:lstStyle xmlns:a="http://schemas.openxmlformats.org/drawingml/2006/main"/>
           <a:p xmlns:a="http://schemas.openxmlformats.org/drawingml/2006/main">
             <a:pPr>
-              <a:defRPr sz="1275" b="1">
+              <a:defRPr sz="1050" b="1">
                 <a:solidFill>
                   <a:srgbClr val="07111F"/>
                 </a:solidFill>
@@ -5885,7 +5890,7 @@
               </a:defRPr>
             </a:pPr>
             <a:r>
-              <a:rPr sz="1275" b="1">
+              <a:rPr sz="1050" b="1">
                 <a:solidFill>
                   <a:srgbClr val="07111F"/>
                 </a:solidFill>
@@ -5893,7 +5898,7 @@
                 <a:ea typeface="Helvetica Neue"/>
                 <a:cs typeface="Helvetica Neue"/>
               </a:rPr>
-              <a:t>Final equity and P&amp;L are read from Alpaca and displayed on the live dashboard after reconciliation.</a:t>
+              <a:t>Baseline evidence only — final equity and P&amp;L remain broker-reconciled paper results, never replay output.</a:t>
             </a:r>
           </a:p>
         </p:txBody>
@@ -5901,7 +5906,7 @@
     </p:spTree>
     <p:extLst>
       <p:ext uri="{BB962C8B-B14F-4D97-AF65-F5344CB8AC3E}">
-        <p14:creationId xmlns:p14="http://schemas.microsoft.com/office/powerpoint/2010/main" val="1146719816"/>
+        <p14:creationId xmlns:p14="http://schemas.microsoft.com/office/powerpoint/2010/main" val="2072661710"/>
       </p:ext>
     </p:extLst>
   </p:cSld>
@@ -5932,7 +5937,7 @@
           <p:cNvPr id="18" name="eyebrow-6">
             <a:extLst xmlns:a="http://schemas.openxmlformats.org/drawingml/2006/main">
               <a:ext uri="{FF2B5EF4-FFF2-40B4-BE49-F238E27FC236}">
-                <a16:creationId xmlns:a16="http://schemas.microsoft.com/office/drawing/2014/main" id="{0E95C45E-FAF2-4809-88A1-F2998E270C3A}"/>
+                <a16:creationId xmlns:a16="http://schemas.microsoft.com/office/drawing/2014/main" id="{A6B10791-9AE9-48B4-80AE-F592C29D6D53}"/>
               </a:ext>
             </a:extLst>
           </p:cNvPr>
@@ -5988,7 +5993,7 @@
           <p:cNvPr id="2" name="title-6">
             <a:extLst xmlns:a="http://schemas.openxmlformats.org/drawingml/2006/main">
               <a:ext uri="{FF2B5EF4-FFF2-40B4-BE49-F238E27FC236}">
-                <a16:creationId xmlns:a16="http://schemas.microsoft.com/office/drawing/2014/main" id="{DFBC1200-CFE5-4267-BF38-7698917CD5BF}"/>
+                <a16:creationId xmlns:a16="http://schemas.microsoft.com/office/drawing/2014/main" id="{825EBD65-7588-499B-BBD1-93D803F01B66}"/>
               </a:ext>
             </a:extLst>
           </p:cNvPr>
@@ -6044,7 +6049,7 @@
           <p:cNvPr id="3" name="slide-number-6">
             <a:extLst xmlns:a="http://schemas.openxmlformats.org/drawingml/2006/main">
               <a:ext uri="{FF2B5EF4-FFF2-40B4-BE49-F238E27FC236}">
-                <a16:creationId xmlns:a16="http://schemas.microsoft.com/office/drawing/2014/main" id="{386A1C26-1EC2-477F-AD5E-98EFC3AF64EB}"/>
+                <a16:creationId xmlns:a16="http://schemas.microsoft.com/office/drawing/2014/main" id="{AE5FEB6E-4FF3-4DFC-A29C-79512FB55D6E}"/>
               </a:ext>
             </a:extLst>
           </p:cNvPr>
@@ -6100,7 +6105,7 @@
           <p:cNvPr id="4" name="future-line">
             <a:extLst xmlns:a="http://schemas.openxmlformats.org/drawingml/2006/main">
               <a:ext uri="{FF2B5EF4-FFF2-40B4-BE49-F238E27FC236}">
-                <a16:creationId xmlns:a16="http://schemas.microsoft.com/office/drawing/2014/main" id="{E76BC51D-A335-4EC8-B31F-EEBF9AC9534B}"/>
+                <a16:creationId xmlns:a16="http://schemas.microsoft.com/office/drawing/2014/main" id="{5F5DE27E-4935-4350-A264-20745E97BCBD}"/>
               </a:ext>
             </a:extLst>
           </p:cNvPr>
@@ -6131,7 +6136,7 @@
           <p:cNvPr id="5" name="future-node-0">
             <a:extLst xmlns:a="http://schemas.openxmlformats.org/drawingml/2006/main">
               <a:ext uri="{FF2B5EF4-FFF2-40B4-BE49-F238E27FC236}">
-                <a16:creationId xmlns:a16="http://schemas.microsoft.com/office/drawing/2014/main" id="{89839757-3374-4B74-9845-B2F6EBB35B06}"/>
+                <a16:creationId xmlns:a16="http://schemas.microsoft.com/office/drawing/2014/main" id="{1CDF9BEF-B2F0-4356-BD25-6259148B839D}"/>
               </a:ext>
             </a:extLst>
           </p:cNvPr>
@@ -6164,7 +6169,7 @@
           <p:cNvPr id="6" name="future-label-0">
             <a:extLst xmlns:a="http://schemas.openxmlformats.org/drawingml/2006/main">
               <a:ext uri="{FF2B5EF4-FFF2-40B4-BE49-F238E27FC236}">
-                <a16:creationId xmlns:a16="http://schemas.microsoft.com/office/drawing/2014/main" id="{0984C10A-F4FF-40D5-9BC8-75AABF65B183}"/>
+                <a16:creationId xmlns:a16="http://schemas.microsoft.com/office/drawing/2014/main" id="{7FE573CF-8A12-4409-81B9-7C00F19D458E}"/>
               </a:ext>
             </a:extLst>
           </p:cNvPr>
@@ -6220,7 +6225,7 @@
           <p:cNvPr id="7" name="future-title-0">
             <a:extLst xmlns:a="http://schemas.openxmlformats.org/drawingml/2006/main">
               <a:ext uri="{FF2B5EF4-FFF2-40B4-BE49-F238E27FC236}">
-                <a16:creationId xmlns:a16="http://schemas.microsoft.com/office/drawing/2014/main" id="{2B934713-9412-4EC7-94EB-3157D7CF7497}"/>
+                <a16:creationId xmlns:a16="http://schemas.microsoft.com/office/drawing/2014/main" id="{679E5D83-FC79-4948-ADEF-309F114E13C8}"/>
               </a:ext>
             </a:extLst>
           </p:cNvPr>
@@ -6276,7 +6281,7 @@
           <p:cNvPr id="8" name="future-body-0">
             <a:extLst xmlns:a="http://schemas.openxmlformats.org/drawingml/2006/main">
               <a:ext uri="{FF2B5EF4-FFF2-40B4-BE49-F238E27FC236}">
-                <a16:creationId xmlns:a16="http://schemas.microsoft.com/office/drawing/2014/main" id="{D0181E02-EA26-4A18-A6DE-DB7B9A366EAF}"/>
+                <a16:creationId xmlns:a16="http://schemas.microsoft.com/office/drawing/2014/main" id="{55820C5E-E896-4DCA-A35E-EB3411CC9345}"/>
               </a:ext>
             </a:extLst>
           </p:cNvPr>
@@ -6332,7 +6337,7 @@
           <p:cNvPr id="9" name="future-node-1">
             <a:extLst xmlns:a="http://schemas.openxmlformats.org/drawingml/2006/main">
               <a:ext uri="{FF2B5EF4-FFF2-40B4-BE49-F238E27FC236}">
-                <a16:creationId xmlns:a16="http://schemas.microsoft.com/office/drawing/2014/main" id="{45887ED3-03B8-4615-AD21-5C93DC197B69}"/>
+                <a16:creationId xmlns:a16="http://schemas.microsoft.com/office/drawing/2014/main" id="{D3294E9A-A71F-4952-A46B-E21C731F839D}"/>
               </a:ext>
             </a:extLst>
           </p:cNvPr>
@@ -6365,7 +6370,7 @@
           <p:cNvPr id="10" name="future-label-1">
             <a:extLst xmlns:a="http://schemas.openxmlformats.org/drawingml/2006/main">
               <a:ext uri="{FF2B5EF4-FFF2-40B4-BE49-F238E27FC236}">
-                <a16:creationId xmlns:a16="http://schemas.microsoft.com/office/drawing/2014/main" id="{0B459F7B-16EC-4567-A9C9-ACA364639528}"/>
+                <a16:creationId xmlns:a16="http://schemas.microsoft.com/office/drawing/2014/main" id="{E3024B01-F6AE-4715-A21C-3AB76CF35135}"/>
               </a:ext>
             </a:extLst>
           </p:cNvPr>
@@ -6421,7 +6426,7 @@
           <p:cNvPr id="11" name="future-title-1">
             <a:extLst xmlns:a="http://schemas.openxmlformats.org/drawingml/2006/main">
               <a:ext uri="{FF2B5EF4-FFF2-40B4-BE49-F238E27FC236}">
-                <a16:creationId xmlns:a16="http://schemas.microsoft.com/office/drawing/2014/main" id="{2B374A48-10CD-4D84-AFB2-806E296A5D6A}"/>
+                <a16:creationId xmlns:a16="http://schemas.microsoft.com/office/drawing/2014/main" id="{7EB6B8CC-2101-40C7-8D1E-35C726959A63}"/>
               </a:ext>
             </a:extLst>
           </p:cNvPr>
@@ -6477,7 +6482,7 @@
           <p:cNvPr id="12" name="future-body-1">
             <a:extLst xmlns:a="http://schemas.openxmlformats.org/drawingml/2006/main">
               <a:ext uri="{FF2B5EF4-FFF2-40B4-BE49-F238E27FC236}">
-                <a16:creationId xmlns:a16="http://schemas.microsoft.com/office/drawing/2014/main" id="{A9489A3C-9528-4F5C-803C-46D280860B3A}"/>
+                <a16:creationId xmlns:a16="http://schemas.microsoft.com/office/drawing/2014/main" id="{54DC8A2D-C8D1-4811-A26A-976B97B5E368}"/>
               </a:ext>
             </a:extLst>
           </p:cNvPr>
@@ -6533,7 +6538,7 @@
           <p:cNvPr id="13" name="future-node-2">
             <a:extLst xmlns:a="http://schemas.openxmlformats.org/drawingml/2006/main">
               <a:ext uri="{FF2B5EF4-FFF2-40B4-BE49-F238E27FC236}">
-                <a16:creationId xmlns:a16="http://schemas.microsoft.com/office/drawing/2014/main" id="{CF24F008-3BE7-4AFF-AFF1-2DB80B84A0B6}"/>
+                <a16:creationId xmlns:a16="http://schemas.microsoft.com/office/drawing/2014/main" id="{D48ACACC-0283-4B08-827C-4F003F8E6608}"/>
               </a:ext>
             </a:extLst>
           </p:cNvPr>
@@ -6566,7 +6571,7 @@
           <p:cNvPr id="14" name="future-label-2">
             <a:extLst xmlns:a="http://schemas.openxmlformats.org/drawingml/2006/main">
               <a:ext uri="{FF2B5EF4-FFF2-40B4-BE49-F238E27FC236}">
-                <a16:creationId xmlns:a16="http://schemas.microsoft.com/office/drawing/2014/main" id="{3F675B5D-28F5-4695-A7DA-DCA62E9BE5A8}"/>
+                <a16:creationId xmlns:a16="http://schemas.microsoft.com/office/drawing/2014/main" id="{580344BC-E3B9-477F-AACD-B6CDA342C130}"/>
               </a:ext>
             </a:extLst>
           </p:cNvPr>
@@ -6622,7 +6627,7 @@
           <p:cNvPr id="15" name="future-title-2">
             <a:extLst xmlns:a="http://schemas.openxmlformats.org/drawingml/2006/main">
               <a:ext uri="{FF2B5EF4-FFF2-40B4-BE49-F238E27FC236}">
-                <a16:creationId xmlns:a16="http://schemas.microsoft.com/office/drawing/2014/main" id="{9A2AD65A-2BA4-4AB2-A563-14346BAC9C7F}"/>
+                <a16:creationId xmlns:a16="http://schemas.microsoft.com/office/drawing/2014/main" id="{67CEC20E-6960-40E1-BEB0-6BA490FC88D0}"/>
               </a:ext>
             </a:extLst>
           </p:cNvPr>
@@ -6678,7 +6683,7 @@
           <p:cNvPr id="16" name="future-body-2">
             <a:extLst xmlns:a="http://schemas.openxmlformats.org/drawingml/2006/main">
               <a:ext uri="{FF2B5EF4-FFF2-40B4-BE49-F238E27FC236}">
-                <a16:creationId xmlns:a16="http://schemas.microsoft.com/office/drawing/2014/main" id="{01B9BE68-9813-4331-851C-FA96D0BEFDF8}"/>
+                <a16:creationId xmlns:a16="http://schemas.microsoft.com/office/drawing/2014/main" id="{B34AAB96-E581-441E-AA0E-C6542EED1D88}"/>
               </a:ext>
             </a:extLst>
           </p:cNvPr>
@@ -6734,7 +6739,7 @@
           <p:cNvPr id="17" name="closing-line">
             <a:extLst xmlns:a="http://schemas.openxmlformats.org/drawingml/2006/main">
               <a:ext uri="{FF2B5EF4-FFF2-40B4-BE49-F238E27FC236}">
-                <a16:creationId xmlns:a16="http://schemas.microsoft.com/office/drawing/2014/main" id="{784598C3-9001-4F23-992D-824A9D36185C}"/>
+                <a16:creationId xmlns:a16="http://schemas.microsoft.com/office/drawing/2014/main" id="{AC644B7C-6389-48E4-8BBC-DDE609F00A15}"/>
               </a:ext>
             </a:extLst>
           </p:cNvPr>
@@ -6788,7 +6793,7 @@
     </p:spTree>
     <p:extLst>
       <p:ext uri="{BB962C8B-B14F-4D97-AF65-F5344CB8AC3E}">
-        <p14:creationId xmlns:p14="http://schemas.microsoft.com/office/powerpoint/2010/main" val="1022078183"/>
+        <p14:creationId xmlns:p14="http://schemas.microsoft.com/office/powerpoint/2010/main" val="2040975387"/>
       </p:ext>
     </p:extLst>
   </p:cSld>

</xml_diff>